<commit_message>
feat: generate PPT with real v8 artifacts + images
- Slide 1: brand avatar (Greek warrior Athena)
- Slide 7: real report data (5 findings, score 2/10, EAS UID)
- Slide 8: S-TIER NFT image + 12,064 combinations
- SVG charts converted to PNG for embedding
- 2.9MB PPTX with Midnight Executive theme
</commit_message>
<xml_diff>
--- a/ppt-assets/Athena-Hackathon.pptx
+++ b/ppt-assets/Athena-Hackathon.pptx
@@ -1676,9 +1676,33 @@
           <a:chExt cx="0" cy="0"/>
         </a:xfrm>
       </p:grpSpPr>
-      <p:sp>
-        <p:nvSpPr>
-          <p:cNvPr id="2" name="Text 0"/>
+      <p:pic>
+        <p:nvPicPr>
+          <p:cNvPr id="2" name="Image 0" descr="/root/projects/glm-code/frontend/images/avatar.png">    </p:cNvPr>
+          <p:cNvPicPr>
+            <a:picLocks noChangeAspect="1"/>
+          </p:cNvPicPr>
+          <p:nvPr/>
+        </p:nvPicPr>
+        <p:blipFill>
+          <a:blip r:embed="rId1"/>
+          <a:stretch>
+            <a:fillRect/>
+          </a:stretch>
+        </p:blipFill>
+        <p:spPr>
+          <a:xfrm>
+            <a:off x="3886200" y="274320"/>
+            <a:ext cx="1371600" cy="1371600"/>
+          </a:xfrm>
+          <a:prstGeom prst="ellipse">
+            <a:avLst/>
+          </a:prstGeom>
+        </p:spPr>
+      </p:pic>
+      <p:sp>
+        <p:nvSpPr>
+          <p:cNvPr id="3" name="Text 0"/>
           <p:cNvSpPr/>
           <p:nvPr/>
         </p:nvSpPr>
@@ -1717,13 +1741,13 @@
       </p:sp>
       <p:sp>
         <p:nvSpPr>
-          <p:cNvPr id="3" name="Text 1"/>
-          <p:cNvSpPr/>
-          <p:nvPr/>
-        </p:nvSpPr>
-        <p:spPr>
-          <a:xfrm>
-            <a:off x="457200" y="2743200"/>
+          <p:cNvPr id="4" name="Text 1"/>
+          <p:cNvSpPr/>
+          <p:nvPr/>
+        </p:nvSpPr>
+        <p:spPr>
+          <a:xfrm>
+            <a:off x="457200" y="2286000"/>
             <a:ext cx="8229600" cy="731520"/>
           </a:xfrm>
           <a:prstGeom prst="rect">
@@ -1756,13 +1780,13 @@
       </p:sp>
       <p:sp>
         <p:nvSpPr>
-          <p:cNvPr id="4" name="Text 2"/>
-          <p:cNvSpPr/>
-          <p:nvPr/>
-        </p:nvSpPr>
-        <p:spPr>
-          <a:xfrm>
-            <a:off x="457200" y="3474720"/>
+          <p:cNvPr id="5" name="Text 2"/>
+          <p:cNvSpPr/>
+          <p:nvPr/>
+        </p:nvSpPr>
+        <p:spPr>
+          <a:xfrm>
+            <a:off x="457200" y="2926080"/>
             <a:ext cx="8229600" cy="548640"/>
           </a:xfrm>
           <a:prstGeom prst="rect">
@@ -1795,13 +1819,13 @@
       </p:sp>
       <p:sp>
         <p:nvSpPr>
-          <p:cNvPr id="5" name="Text 3"/>
-          <p:cNvSpPr/>
-          <p:nvPr/>
-        </p:nvSpPr>
-        <p:spPr>
-          <a:xfrm>
-            <a:off x="457200" y="4114800"/>
+          <p:cNvPr id="6" name="Text 3"/>
+          <p:cNvSpPr/>
+          <p:nvPr/>
+        </p:nvSpPr>
+        <p:spPr>
+          <a:xfrm>
+            <a:off x="457200" y="3474720"/>
             <a:ext cx="8229600" cy="457200"/>
           </a:xfrm>
           <a:prstGeom prst="rect">
@@ -1834,7 +1858,7 @@
       </p:sp>
       <p:sp>
         <p:nvSpPr>
-          <p:cNvPr id="6" name="Text 4"/>
+          <p:cNvPr id="7" name="Text 4"/>
           <p:cNvSpPr/>
           <p:nvPr/>
         </p:nvSpPr>
@@ -4596,7 +4620,7 @@
                 <a:ea typeface="Arial" pitchFamily="34" charset="-122"/>
                 <a:cs typeface="Arial" pitchFamily="34" charset="-120"/>
               </a:rPr>
-              <a:t>Agent 的产出：审计报告 + 链上验证</a:t>
+              <a:t>审计报告 + 链上验证</a:t>
             </a:r>
             <a:endParaRPr lang="en-US" sz="2800" dirty="0"/>
           </a:p>
@@ -4610,8 +4634,8 @@
         </p:nvSpPr>
         <p:spPr>
           <a:xfrm>
-            <a:off x="457200" y="1188720"/>
-            <a:ext cx="3840480" cy="3200400"/>
+            <a:off x="457200" y="1097280"/>
+            <a:ext cx="3840480" cy="3657600"/>
           </a:xfrm>
           <a:prstGeom prst="rect">
             <a:avLst/>
@@ -4635,7 +4659,7 @@
         </p:nvSpPr>
         <p:spPr>
           <a:xfrm>
-            <a:off x="640080" y="1280160"/>
+            <a:off x="640080" y="1188720"/>
             <a:ext cx="3474720" cy="457200"/>
           </a:xfrm>
           <a:prstGeom prst="rect">
@@ -4652,7 +4676,7 @@
               <a:buNone/>
             </a:pPr>
             <a:r>
-              <a:rPr lang="en-US" sz="1600" b="1" dirty="0">
+              <a:rPr lang="en-US" sz="1400" b="1" dirty="0">
                 <a:solidFill>
                   <a:srgbClr val="4A90D9"/>
                 </a:solidFill>
@@ -4660,9 +4684,9 @@
                 <a:ea typeface="Arial" pitchFamily="34" charset="-122"/>
                 <a:cs typeface="Arial" pitchFamily="34" charset="-120"/>
               </a:rPr>
-              <a:t>审计报告示例</a:t>
-            </a:r>
-            <a:endParaRPr lang="en-US" sz="1600" dirty="0"/>
+              <a:t>审计报告：DeFi Protocol</a:t>
+            </a:r>
+            <a:endParaRPr lang="en-US" sz="1400" dirty="0"/>
           </a:p>
         </p:txBody>
       </p:sp>
@@ -4674,8 +4698,8 @@
         </p:nvSpPr>
         <p:spPr>
           <a:xfrm>
-            <a:off x="640080" y="1828800"/>
-            <a:ext cx="3474720" cy="2286000"/>
+            <a:off x="640080" y="1645920"/>
+            <a:ext cx="3474720" cy="2926080"/>
           </a:xfrm>
           <a:prstGeom prst="rect">
             <a:avLst/>
@@ -4691,121 +4715,138 @@
               <a:buNone/>
             </a:pPr>
             <a:r>
-              <a:rPr lang="en-US" sz="1200" b="1" dirty="0">
-                <a:solidFill>
-                  <a:srgbClr val="888888"/>
-                </a:solidFill>
-                <a:latin typeface="Arial" pitchFamily="34" charset="0"/>
-                <a:ea typeface="Arial" pitchFamily="34" charset="-122"/>
-                <a:cs typeface="Arial" pitchFamily="34" charset="-120"/>
-              </a:rPr>
-              <a:t>DeFi Protocol Audit</a:t>
-            </a:r>
-            <a:endParaRPr lang="en-US" sz="1200" dirty="0"/>
-          </a:p>
-          <a:p>
-            <a:pPr algn="l" indent="0" marL="0">
-              <a:buNone/>
-            </a:pPr>
-            <a:endParaRPr lang="en-US" sz="1200" dirty="0"/>
-          </a:p>
-          <a:p>
-            <a:pPr algn="l" indent="0" marL="0">
-              <a:buNone/>
-            </a:pPr>
-            <a:r>
-              <a:rPr lang="en-US" sz="1200" dirty="0">
-                <a:solidFill>
-                  <a:srgbClr val="888888"/>
-                </a:solidFill>
-                <a:latin typeface="Arial" pitchFamily="34" charset="0"/>
-                <a:ea typeface="Arial" pitchFamily="34" charset="-122"/>
-                <a:cs typeface="Arial" pitchFamily="34" charset="-120"/>
-              </a:rPr>
-              <a:t>5 个漏洞发现：</a:t>
-            </a:r>
-            <a:endParaRPr lang="en-US" sz="1200" dirty="0"/>
-          </a:p>
-          <a:p>
-            <a:pPr algn="l" indent="0" marL="0">
-              <a:buNone/>
-            </a:pPr>
-            <a:r>
-              <a:rPr lang="en-US" sz="1200" dirty="0">
-                <a:solidFill>
-                  <a:srgbClr val="888888"/>
-                </a:solidFill>
-                <a:latin typeface="Arial" pitchFamily="34" charset="0"/>
-                <a:ea typeface="Arial" pitchFamily="34" charset="-122"/>
-                <a:cs typeface="Arial" pitchFamily="34" charset="-120"/>
-              </a:rPr>
-              <a:t>• 1 Critical (Reentrancy)</a:t>
-            </a:r>
-            <a:endParaRPr lang="en-US" sz="1200" dirty="0"/>
-          </a:p>
-          <a:p>
-            <a:pPr algn="l" indent="0" marL="0">
-              <a:buNone/>
-            </a:pPr>
-            <a:r>
-              <a:rPr lang="en-US" sz="1200" dirty="0">
-                <a:solidFill>
-                  <a:srgbClr val="888888"/>
-                </a:solidFill>
-                <a:latin typeface="Arial" pitchFamily="34" charset="0"/>
-                <a:ea typeface="Arial" pitchFamily="34" charset="-122"/>
-                <a:cs typeface="Arial" pitchFamily="34" charset="-120"/>
-              </a:rPr>
-              <a:t>• 2 High (Oracle + Flash Loan)</a:t>
-            </a:r>
-            <a:endParaRPr lang="en-US" sz="1200" dirty="0"/>
-          </a:p>
-          <a:p>
-            <a:pPr algn="l" indent="0" marL="0">
-              <a:buNone/>
-            </a:pPr>
-            <a:r>
-              <a:rPr lang="en-US" sz="1200" dirty="0">
-                <a:solidFill>
-                  <a:srgbClr val="888888"/>
-                </a:solidFill>
-                <a:latin typeface="Arial" pitchFamily="34" charset="0"/>
-                <a:ea typeface="Arial" pitchFamily="34" charset="-122"/>
-                <a:cs typeface="Arial" pitchFamily="34" charset="-120"/>
-              </a:rPr>
-              <a:t>• 1 Medium (Access Control)</a:t>
-            </a:r>
-            <a:endParaRPr lang="en-US" sz="1200" dirty="0"/>
-          </a:p>
-          <a:p>
-            <a:pPr algn="l" indent="0" marL="0">
-              <a:buNone/>
-            </a:pPr>
-            <a:r>
-              <a:rPr lang="en-US" sz="1200" dirty="0">
-                <a:solidFill>
-                  <a:srgbClr val="888888"/>
-                </a:solidFill>
-                <a:latin typeface="Arial" pitchFamily="34" charset="0"/>
-                <a:ea typeface="Arial" pitchFamily="34" charset="-122"/>
-                <a:cs typeface="Arial" pitchFamily="34" charset="-120"/>
-              </a:rPr>
-              <a:t>• 1 Low (Gas Optimization)</a:t>
-            </a:r>
-            <a:endParaRPr lang="en-US" sz="1200" dirty="0"/>
-          </a:p>
-          <a:p>
-            <a:pPr algn="l" indent="0" marL="0">
-              <a:buNone/>
-            </a:pPr>
-            <a:endParaRPr lang="en-US" sz="1200" dirty="0"/>
-          </a:p>
-          <a:p>
-            <a:pPr algn="l" indent="0" marL="0">
-              <a:buNone/>
-            </a:pPr>
-            <a:r>
-              <a:rPr lang="en-US" sz="1200" dirty="0">
+              <a:rPr lang="en-US" sz="1000" b="1" dirty="0">
+                <a:solidFill>
+                  <a:srgbClr val="FF0000"/>
+                </a:solidFill>
+                <a:latin typeface="Arial" pitchFamily="34" charset="0"/>
+                <a:ea typeface="Arial" pitchFamily="34" charset="-122"/>
+                <a:cs typeface="Arial" pitchFamily="34" charset="-120"/>
+              </a:rPr>
+              <a:t>安全评分：2/10</a:t>
+            </a:r>
+            <a:endParaRPr lang="en-US" sz="1000" dirty="0"/>
+          </a:p>
+          <a:p>
+            <a:pPr algn="l" indent="0" marL="0">
+              <a:buNone/>
+            </a:pPr>
+            <a:endParaRPr lang="en-US" sz="1000" dirty="0"/>
+          </a:p>
+          <a:p>
+            <a:pPr algn="l" indent="0" marL="0">
+              <a:buNone/>
+            </a:pPr>
+            <a:r>
+              <a:rPr lang="en-US" sz="1000" b="1" dirty="0">
+                <a:solidFill>
+                  <a:srgbClr val="888888"/>
+                </a:solidFill>
+                <a:latin typeface="Arial" pitchFamily="34" charset="0"/>
+                <a:ea typeface="Arial" pitchFamily="34" charset="-122"/>
+                <a:cs typeface="Arial" pitchFamily="34" charset="-120"/>
+              </a:rPr>
+              <a:t>漏洞发现（5 个）：</a:t>
+            </a:r>
+            <a:endParaRPr lang="en-US" sz="1000" dirty="0"/>
+          </a:p>
+          <a:p>
+            <a:pPr algn="l" indent="0" marL="0">
+              <a:buNone/>
+            </a:pPr>
+            <a:r>
+              <a:rPr lang="en-US" sz="1000" dirty="0">
+                <a:solidFill>
+                  <a:srgbClr val="FF0000"/>
+                </a:solidFill>
+                <a:latin typeface="Arial" pitchFamily="34" charset="0"/>
+                <a:ea typeface="Arial" pitchFamily="34" charset="-122"/>
+                <a:cs typeface="Arial" pitchFamily="34" charset="-120"/>
+              </a:rPr>
+              <a:t>● Critical: Reentrancy (Vault.withdraw) 95%</a:t>
+            </a:r>
+            <a:endParaRPr lang="en-US" sz="1000" dirty="0"/>
+          </a:p>
+          <a:p>
+            <a:pPr algn="l" indent="0" marL="0">
+              <a:buNone/>
+            </a:pPr>
+            <a:r>
+              <a:rPr lang="en-US" sz="1000" dirty="0">
+                <a:solidFill>
+                  <a:srgbClr val="FF8800"/>
+                </a:solidFill>
+                <a:latin typeface="Arial" pitchFamily="34" charset="0"/>
+                <a:ea typeface="Arial" pitchFamily="34" charset="-122"/>
+                <a:cs typeface="Arial" pitchFamily="34" charset="-120"/>
+              </a:rPr>
+              <a:t>● High: Oracle 价格操纵 90%</a:t>
+            </a:r>
+            <a:endParaRPr lang="en-US" sz="1000" dirty="0"/>
+          </a:p>
+          <a:p>
+            <a:pPr algn="l" indent="0" marL="0">
+              <a:buNone/>
+            </a:pPr>
+            <a:r>
+              <a:rPr lang="en-US" sz="1000" dirty="0">
+                <a:solidFill>
+                  <a:srgbClr val="FF8800"/>
+                </a:solidFill>
+                <a:latin typeface="Arial" pitchFamily="34" charset="0"/>
+                <a:ea typeface="Arial" pitchFamily="34" charset="-122"/>
+                <a:cs typeface="Arial" pitchFamily="34" charset="-120"/>
+              </a:rPr>
+              <a:t>● High: 缺少访问控制 88%</a:t>
+            </a:r>
+            <a:endParaRPr lang="en-US" sz="1000" dirty="0"/>
+          </a:p>
+          <a:p>
+            <a:pPr algn="l" indent="0" marL="0">
+              <a:buNone/>
+            </a:pPr>
+            <a:r>
+              <a:rPr lang="en-US" sz="1000" dirty="0">
+                <a:solidFill>
+                  <a:srgbClr val="FFFF00"/>
+                </a:solidFill>
+                <a:latin typeface="Arial" pitchFamily="34" charset="0"/>
+                <a:ea typeface="Arial" pitchFamily="34" charset="-122"/>
+                <a:cs typeface="Arial" pitchFamily="34" charset="-120"/>
+              </a:rPr>
+              <a:t>● Medium: 整数溢出 80%</a:t>
+            </a:r>
+            <a:endParaRPr lang="en-US" sz="1000" dirty="0"/>
+          </a:p>
+          <a:p>
+            <a:pPr algn="l" indent="0" marL="0">
+              <a:buNone/>
+            </a:pPr>
+            <a:r>
+              <a:rPr lang="en-US" sz="1000" dirty="0">
+                <a:solidFill>
+                  <a:srgbClr val="0088FF"/>
+                </a:solidFill>
+                <a:latin typeface="Arial" pitchFamily="34" charset="0"/>
+                <a:ea typeface="Arial" pitchFamily="34" charset="-122"/>
+                <a:cs typeface="Arial" pitchFamily="34" charset="-120"/>
+              </a:rPr>
+              <a:t>● Low: 未初始化存储 70%</a:t>
+            </a:r>
+            <a:endParaRPr lang="en-US" sz="1000" dirty="0"/>
+          </a:p>
+          <a:p>
+            <a:pPr algn="l" indent="0" marL="0">
+              <a:buNone/>
+            </a:pPr>
+            <a:endParaRPr lang="en-US" sz="1000" dirty="0"/>
+          </a:p>
+          <a:p>
+            <a:pPr algn="l" indent="0" marL="0">
+              <a:buNone/>
+            </a:pPr>
+            <a:r>
+              <a:rPr lang="en-US" sz="1000" dirty="0">
                 <a:solidFill>
                   <a:srgbClr val="888888"/>
                 </a:solidFill>
@@ -4815,24 +4856,24 @@
               </a:rPr>
               <a:t>攻击模拟：$2.3M 预计损失</a:t>
             </a:r>
-            <a:endParaRPr lang="en-US" sz="1200" dirty="0"/>
-          </a:p>
-          <a:p>
-            <a:pPr algn="l" indent="0" marL="0">
-              <a:buNone/>
-            </a:pPr>
-            <a:r>
-              <a:rPr lang="en-US" sz="1200" dirty="0">
-                <a:solidFill>
-                  <a:srgbClr val="888888"/>
-                </a:solidFill>
-                <a:latin typeface="Arial" pitchFamily="34" charset="0"/>
-                <a:ea typeface="Arial" pitchFamily="34" charset="-122"/>
-                <a:cs typeface="Arial" pitchFamily="34" charset="-120"/>
-              </a:rPr>
-              <a:t>PoC 验证：Foundry 256 runs</a:t>
-            </a:r>
-            <a:endParaRPr lang="en-US" sz="1200" dirty="0"/>
+            <a:endParaRPr lang="en-US" sz="1000" dirty="0"/>
+          </a:p>
+          <a:p>
+            <a:pPr algn="l" indent="0" marL="0">
+              <a:buNone/>
+            </a:pPr>
+            <a:r>
+              <a:rPr lang="en-US" sz="1000" dirty="0">
+                <a:solidFill>
+                  <a:srgbClr val="888888"/>
+                </a:solidFill>
+                <a:latin typeface="Arial" pitchFamily="34" charset="0"/>
+                <a:ea typeface="Arial" pitchFamily="34" charset="-122"/>
+                <a:cs typeface="Arial" pitchFamily="34" charset="-120"/>
+              </a:rPr>
+              <a:t>PoC 验证：Foundry 256 runs ✓</a:t>
+            </a:r>
+            <a:endParaRPr lang="en-US" sz="1000" dirty="0"/>
           </a:p>
         </p:txBody>
       </p:sp>
@@ -4844,8 +4885,8 @@
         </p:nvSpPr>
         <p:spPr>
           <a:xfrm>
-            <a:off x="4846320" y="1188720"/>
-            <a:ext cx="3840480" cy="3200400"/>
+            <a:off x="4846320" y="1097280"/>
+            <a:ext cx="3840480" cy="3657600"/>
           </a:xfrm>
           <a:prstGeom prst="rect">
             <a:avLst/>
@@ -4869,7 +4910,7 @@
         </p:nvSpPr>
         <p:spPr>
           <a:xfrm>
-            <a:off x="5029200" y="1280160"/>
+            <a:off x="5029200" y="1188720"/>
             <a:ext cx="3474720" cy="457200"/>
           </a:xfrm>
           <a:prstGeom prst="rect">
@@ -4886,7 +4927,7 @@
               <a:buNone/>
             </a:pPr>
             <a:r>
-              <a:rPr lang="en-US" sz="1600" b="1" dirty="0">
+              <a:rPr lang="en-US" sz="1400" b="1" dirty="0">
                 <a:solidFill>
                   <a:srgbClr val="D4A535"/>
                 </a:solidFill>
@@ -4896,7 +4937,7 @@
               </a:rPr>
               <a:t>链上认证（EAS）</a:t>
             </a:r>
-            <a:endParaRPr lang="en-US" sz="1600" dirty="0"/>
+            <a:endParaRPr lang="en-US" sz="1400" dirty="0"/>
           </a:p>
         </p:txBody>
       </p:sp>
@@ -4908,8 +4949,8 @@
         </p:nvSpPr>
         <p:spPr>
           <a:xfrm>
-            <a:off x="5029200" y="1828800"/>
-            <a:ext cx="3474720" cy="2286000"/>
+            <a:off x="5029200" y="1645920"/>
+            <a:ext cx="3474720" cy="2926080"/>
           </a:xfrm>
           <a:prstGeom prst="rect">
             <a:avLst/>
@@ -4925,7 +4966,7 @@
               <a:buNone/>
             </a:pPr>
             <a:r>
-              <a:rPr lang="en-US" sz="1400" dirty="0">
+              <a:rPr lang="en-US" sz="1100" dirty="0">
                 <a:solidFill>
                   <a:srgbClr val="00FF00"/>
                 </a:solidFill>
@@ -4933,16 +4974,22 @@
                 <a:ea typeface="Arial" pitchFamily="34" charset="-122"/>
                 <a:cs typeface="Arial" pitchFamily="34" charset="-120"/>
               </a:rPr>
-              <a:t>✓ 不可篡改</a:t>
-            </a:r>
-            <a:endParaRPr lang="en-US" sz="1400" dirty="0"/>
-          </a:p>
-          <a:p>
-            <a:pPr algn="l" indent="0" marL="0">
-              <a:buNone/>
-            </a:pPr>
-            <a:r>
-              <a:rPr lang="en-US" sz="1400" dirty="0">
+              <a:t>✓ 不可篡改 · 可验证 · 可追溯</a:t>
+            </a:r>
+            <a:endParaRPr lang="en-US" sz="1100" dirty="0"/>
+          </a:p>
+          <a:p>
+            <a:pPr algn="l" indent="0" marL="0">
+              <a:buNone/>
+            </a:pPr>
+            <a:endParaRPr lang="en-US" sz="1100" dirty="0"/>
+          </a:p>
+          <a:p>
+            <a:pPr algn="l" indent="0" marL="0">
+              <a:buNone/>
+            </a:pPr>
+            <a:r>
+              <a:rPr lang="en-US" sz="1100" b="1" dirty="0">
                 <a:solidFill>
                   <a:srgbClr val="00FF00"/>
                 </a:solidFill>
@@ -4950,16 +4997,16 @@
                 <a:ea typeface="Arial" pitchFamily="34" charset="-122"/>
                 <a:cs typeface="Arial" pitchFamily="34" charset="-120"/>
               </a:rPr>
-              <a:t>✓ 可验证</a:t>
-            </a:r>
-            <a:endParaRPr lang="en-US" sz="1400" dirty="0"/>
-          </a:p>
-          <a:p>
-            <a:pPr algn="l" indent="0" marL="0">
-              <a:buNone/>
-            </a:pPr>
-            <a:r>
-              <a:rPr lang="en-US" sz="1400" dirty="0">
+              <a:t>EAS Attestation UID:</a:t>
+            </a:r>
+            <a:endParaRPr lang="en-US" sz="1100" dirty="0"/>
+          </a:p>
+          <a:p>
+            <a:pPr algn="l" indent="0" marL="0">
+              <a:buNone/>
+            </a:pPr>
+            <a:r>
+              <a:rPr lang="en-US" sz="1100" dirty="0">
                 <a:solidFill>
                   <a:srgbClr val="00FF00"/>
                 </a:solidFill>
@@ -4967,22 +5014,22 @@
                 <a:ea typeface="Arial" pitchFamily="34" charset="-122"/>
                 <a:cs typeface="Arial" pitchFamily="34" charset="-120"/>
               </a:rPr>
-              <a:t>✓ 可追溯</a:t>
-            </a:r>
-            <a:endParaRPr lang="en-US" sz="1400" dirty="0"/>
-          </a:p>
-          <a:p>
-            <a:pPr algn="l" indent="0" marL="0">
-              <a:buNone/>
-            </a:pPr>
-            <a:endParaRPr lang="en-US" sz="1400" dirty="0"/>
-          </a:p>
-          <a:p>
-            <a:pPr algn="l" indent="0" marL="0">
-              <a:buNone/>
-            </a:pPr>
-            <a:r>
-              <a:rPr lang="en-US" sz="1400" dirty="0">
+              <a:t>0xd02800c960f18f...</a:t>
+            </a:r>
+            <a:endParaRPr lang="en-US" sz="1100" dirty="0"/>
+          </a:p>
+          <a:p>
+            <a:pPr algn="l" indent="0" marL="0">
+              <a:buNone/>
+            </a:pPr>
+            <a:endParaRPr lang="en-US" sz="1100" dirty="0"/>
+          </a:p>
+          <a:p>
+            <a:pPr algn="l" indent="0" marL="0">
+              <a:buNone/>
+            </a:pPr>
+            <a:r>
+              <a:rPr lang="en-US" sz="1100" dirty="0">
                 <a:solidFill>
                   <a:srgbClr val="00FF00"/>
                 </a:solidFill>
@@ -4990,16 +5037,39 @@
                 <a:ea typeface="Arial" pitchFamily="34" charset="-122"/>
                 <a:cs typeface="Arial" pitchFamily="34" charset="-120"/>
               </a:rPr>
+              <a:t>合约：0x3247d57d...</a:t>
+            </a:r>
+            <a:endParaRPr lang="en-US" sz="1100" dirty="0"/>
+          </a:p>
+          <a:p>
+            <a:pPr algn="l" indent="0" marL="0">
+              <a:buNone/>
+            </a:pPr>
+            <a:endParaRPr lang="en-US" sz="1100" dirty="0"/>
+          </a:p>
+          <a:p>
+            <a:pPr algn="l" indent="0" marL="0">
+              <a:buNone/>
+            </a:pPr>
+            <a:r>
+              <a:rPr lang="en-US" sz="1100" dirty="0">
+                <a:solidFill>
+                  <a:srgbClr val="00FF00"/>
+                </a:solidFill>
+                <a:latin typeface="Arial" pitchFamily="34" charset="0"/>
+                <a:ea typeface="Arial" pitchFamily="34" charset="-122"/>
+                <a:cs typeface="Arial" pitchFamily="34" charset="-120"/>
+              </a:rPr>
               <a:t>Sepolia 测试网</a:t>
             </a:r>
-            <a:endParaRPr lang="en-US" sz="1400" dirty="0"/>
-          </a:p>
-          <a:p>
-            <a:pPr algn="l" indent="0" marL="0">
-              <a:buNone/>
-            </a:pPr>
-            <a:r>
-              <a:rPr lang="en-US" sz="1400" dirty="0">
+            <a:endParaRPr lang="en-US" sz="1100" dirty="0"/>
+          </a:p>
+          <a:p>
+            <a:pPr algn="l" indent="0" marL="0">
+              <a:buNone/>
+            </a:pPr>
+            <a:r>
+              <a:rPr lang="en-US" sz="1100" dirty="0">
                 <a:solidFill>
                   <a:srgbClr val="00FF00"/>
                 </a:solidFill>
@@ -5009,7 +5079,47 @@
               </a:rPr>
               <a:t>零成本验证</a:t>
             </a:r>
-            <a:endParaRPr lang="en-US" sz="1400" dirty="0"/>
+            <a:endParaRPr lang="en-US" sz="1100" dirty="0"/>
+          </a:p>
+          <a:p>
+            <a:pPr algn="l" indent="0" marL="0">
+              <a:buNone/>
+            </a:pPr>
+            <a:endParaRPr lang="en-US" sz="1100" dirty="0"/>
+          </a:p>
+          <a:p>
+            <a:pPr algn="l" indent="0" marL="0">
+              <a:buNone/>
+            </a:pPr>
+            <a:r>
+              <a:rPr lang="en-US" sz="1100" dirty="0">
+                <a:solidFill>
+                  <a:srgbClr val="4A90D9"/>
+                </a:solidFill>
+                <a:latin typeface="Arial" pitchFamily="34" charset="0"/>
+                <a:ea typeface="Arial" pitchFamily="34" charset="-122"/>
+                <a:cs typeface="Arial" pitchFamily="34" charset="-120"/>
+              </a:rPr>
+              <a:t>查看验证 →</a:t>
+            </a:r>
+            <a:endParaRPr lang="en-US" sz="1100" dirty="0"/>
+          </a:p>
+          <a:p>
+            <a:pPr algn="l" indent="0" marL="0">
+              <a:buNone/>
+            </a:pPr>
+            <a:r>
+              <a:rPr lang="en-US" sz="800" dirty="0">
+                <a:solidFill>
+                  <a:srgbClr val="4A90D9"/>
+                </a:solidFill>
+                <a:latin typeface="Arial" pitchFamily="34" charset="0"/>
+                <a:ea typeface="Arial" pitchFamily="34" charset="-122"/>
+                <a:cs typeface="Arial" pitchFamily="34" charset="-120"/>
+              </a:rPr>
+              <a:t>sepolia.easscan.org</a:t>
+            </a:r>
+            <a:endParaRPr lang="en-US" sz="1100" dirty="0"/>
           </a:p>
         </p:txBody>
       </p:sp>
@@ -5114,22 +5224,85 @@
                 <a:ea typeface="Arial" pitchFamily="34" charset="-122"/>
                 <a:cs typeface="Arial" pitchFamily="34" charset="-120"/>
               </a:rPr>
-              <a:t>Agent 的经济产出：Generative NFT</a:t>
+              <a:t>Generative NFT 审计证书</a:t>
             </a:r>
             <a:endParaRPr lang="en-US" sz="2800" dirty="0"/>
           </a:p>
         </p:txBody>
       </p:sp>
-      <p:sp>
-        <p:nvSpPr>
-          <p:cNvPr id="3" name="Shape 1"/>
-          <p:cNvSpPr/>
-          <p:nvPr/>
-        </p:nvSpPr>
-        <p:spPr>
-          <a:xfrm>
-            <a:off x="457200" y="1188720"/>
-            <a:ext cx="8229600" cy="3474720"/>
+      <p:pic>
+        <p:nvPicPr>
+          <p:cNvPr id="3" name="Image 0" descr="/root/projects/glm-code/frontend/images/nft-s-tier.png">    </p:cNvPr>
+          <p:cNvPicPr>
+            <a:picLocks noChangeAspect="1"/>
+          </p:cNvPicPr>
+          <p:nvPr/>
+        </p:nvPicPr>
+        <p:blipFill>
+          <a:blip r:embed="rId1"/>
+          <a:stretch>
+            <a:fillRect/>
+          </a:stretch>
+        </p:blipFill>
+        <p:spPr>
+          <a:xfrm>
+            <a:off x="2743200" y="1097280"/>
+            <a:ext cx="3657600" cy="3566160"/>
+          </a:xfrm>
+          <a:prstGeom prst="rect">
+            <a:avLst/>
+          </a:prstGeom>
+        </p:spPr>
+      </p:pic>
+      <p:sp>
+        <p:nvSpPr>
+          <p:cNvPr id="4" name="Text 1"/>
+          <p:cNvSpPr/>
+          <p:nvPr/>
+        </p:nvSpPr>
+        <p:spPr>
+          <a:xfrm>
+            <a:off x="2743200" y="4572000"/>
+            <a:ext cx="3657600" cy="365760"/>
+          </a:xfrm>
+          <a:prstGeom prst="rect">
+            <a:avLst/>
+          </a:prstGeom>
+          <a:noFill/>
+          <a:ln/>
+        </p:spPr>
+        <p:txBody>
+          <a:bodyPr wrap="square" rtlCol="0" anchor="ctr"/>
+          <a:lstStyle/>
+          <a:p>
+            <a:pPr algn="ctr" indent="0" marL="0">
+              <a:buNone/>
+            </a:pPr>
+            <a:r>
+              <a:rPr lang="en-US" sz="1600" b="1" dirty="0">
+                <a:solidFill>
+                  <a:srgbClr val="D4A535"/>
+                </a:solidFill>
+                <a:latin typeface="Arial" pitchFamily="34" charset="0"/>
+                <a:ea typeface="Arial" pitchFamily="34" charset="-122"/>
+                <a:cs typeface="Arial" pitchFamily="34" charset="-120"/>
+              </a:rPr>
+              <a:t>S-TIER · Gold NFT</a:t>
+            </a:r>
+            <a:endParaRPr lang="en-US" sz="1600" dirty="0"/>
+          </a:p>
+        </p:txBody>
+      </p:sp>
+      <p:sp>
+        <p:nvSpPr>
+          <p:cNvPr id="5" name="Shape 2"/>
+          <p:cNvSpPr/>
+          <p:nvPr/>
+        </p:nvSpPr>
+        <p:spPr>
+          <a:xfrm>
+            <a:off x="274320" y="1097280"/>
+            <a:ext cx="2286000" cy="3566160"/>
           </a:xfrm>
           <a:prstGeom prst="rect">
             <a:avLst/>
@@ -5137,7 +5310,7 @@
           <a:solidFill>
             <a:srgbClr val="1A1F3A"/>
           </a:solidFill>
-          <a:ln w="25400">
+          <a:ln w="12700">
             <a:solidFill>
               <a:srgbClr val="D4A535"/>
             </a:solidFill>
@@ -5147,14 +5320,14 @@
       </p:sp>
       <p:sp>
         <p:nvSpPr>
-          <p:cNvPr id="4" name="Text 2"/>
-          <p:cNvSpPr/>
-          <p:nvPr/>
-        </p:nvSpPr>
-        <p:spPr>
-          <a:xfrm>
-            <a:off x="914400" y="1371600"/>
-            <a:ext cx="7315200" cy="3108960"/>
+          <p:cNvPr id="6" name="Text 3"/>
+          <p:cNvSpPr/>
+          <p:nvPr/>
+        </p:nvSpPr>
+        <p:spPr>
+          <a:xfrm>
+            <a:off x="457200" y="1371600"/>
+            <a:ext cx="1920240" cy="2926080"/>
           </a:xfrm>
           <a:prstGeom prst="rect">
             <a:avLst/>
@@ -5166,34 +5339,195 @@
           <a:bodyPr wrap="square" rtlCol="0" anchor="t"/>
           <a:lstStyle/>
           <a:p>
-            <a:pPr algn="l" indent="0" marL="0">
+            <a:pPr algn="ctr" indent="0" marL="0">
+              <a:buNone/>
+            </a:pPr>
+            <a:r>
+              <a:rPr lang="en-US" sz="2000" b="1" dirty="0">
+                <a:solidFill>
+                  <a:srgbClr val="D4A535"/>
+                </a:solidFill>
+                <a:latin typeface="Arial" pitchFamily="34" charset="0"/>
+                <a:ea typeface="Arial" pitchFamily="34" charset="-122"/>
+                <a:cs typeface="Arial" pitchFamily="34" charset="-120"/>
+              </a:rPr>
+              <a:t>12,064</a:t>
+            </a:r>
+            <a:endParaRPr lang="en-US" sz="2000" dirty="0"/>
+          </a:p>
+          <a:p>
+            <a:pPr algn="ctr" indent="0" marL="0">
+              <a:buNone/>
+            </a:pPr>
+            <a:r>
+              <a:rPr lang="en-US" sz="1000" dirty="0">
+                <a:solidFill>
+                  <a:srgbClr val="888888"/>
+                </a:solidFill>
+                <a:latin typeface="Arial" pitchFamily="34" charset="0"/>
+                <a:ea typeface="Arial" pitchFamily="34" charset="-122"/>
+                <a:cs typeface="Arial" pitchFamily="34" charset="-120"/>
+              </a:rPr>
+              <a:t>Trait 组合</a:t>
+            </a:r>
+            <a:endParaRPr lang="en-US" sz="2000" dirty="0"/>
+          </a:p>
+          <a:p>
+            <a:pPr algn="ctr" indent="0" marL="0">
+              <a:buNone/>
+            </a:pPr>
+            <a:endParaRPr lang="en-US" sz="2000" dirty="0"/>
+          </a:p>
+          <a:p>
+            <a:pPr algn="ctr" indent="0" marL="0">
+              <a:buNone/>
+            </a:pPr>
+            <a:r>
+              <a:rPr lang="en-US" sz="1200" b="1" dirty="0">
+                <a:solidFill>
+                  <a:srgbClr val="FFFFFF"/>
+                </a:solidFill>
+                <a:latin typeface="Arial" pitchFamily="34" charset="0"/>
+                <a:ea typeface="Arial" pitchFamily="34" charset="-122"/>
+                <a:cs typeface="Arial" pitchFamily="34" charset="-120"/>
+              </a:rPr>
+              <a:t>S/A/B/C 四级</a:t>
+            </a:r>
+            <a:endParaRPr lang="en-US" sz="2000" dirty="0"/>
+          </a:p>
+          <a:p>
+            <a:pPr algn="ctr" indent="0" marL="0">
+              <a:buNone/>
+            </a:pPr>
+            <a:r>
+              <a:rPr lang="en-US" sz="1000" dirty="0">
+                <a:solidFill>
+                  <a:srgbClr val="888888"/>
+                </a:solidFill>
+                <a:latin typeface="Arial" pitchFamily="34" charset="0"/>
+                <a:ea typeface="Arial" pitchFamily="34" charset="-122"/>
+                <a:cs typeface="Arial" pitchFamily="34" charset="-120"/>
+              </a:rPr>
+              <a:t>OpenRarity 算法</a:t>
+            </a:r>
+            <a:endParaRPr lang="en-US" sz="2000" dirty="0"/>
+          </a:p>
+          <a:p>
+            <a:pPr algn="ctr" indent="0" marL="0">
+              <a:buNone/>
+            </a:pPr>
+            <a:endParaRPr lang="en-US" sz="2000" dirty="0"/>
+          </a:p>
+          <a:p>
+            <a:pPr algn="ctr" indent="0" marL="0">
+              <a:buNone/>
+            </a:pPr>
+            <a:r>
+              <a:rPr lang="en-US" sz="1200" b="1" dirty="0">
+                <a:solidFill>
+                  <a:srgbClr val="D4A535"/>
+                </a:solidFill>
+                <a:latin typeface="Arial" pitchFamily="34" charset="0"/>
+                <a:ea typeface="Arial" pitchFamily="34" charset="-122"/>
+                <a:cs typeface="Arial" pitchFamily="34" charset="-120"/>
+              </a:rPr>
+              <a:t>Token #1</a:t>
+            </a:r>
+            <a:endParaRPr lang="en-US" sz="2000" dirty="0"/>
+          </a:p>
+          <a:p>
+            <a:pPr algn="ctr" indent="0" marL="0">
+              <a:buNone/>
+            </a:pPr>
+            <a:r>
+              <a:rPr lang="en-US" sz="1000" dirty="0">
+                <a:solidFill>
+                  <a:srgbClr val="00FF00"/>
+                </a:solidFill>
+                <a:latin typeface="Arial" pitchFamily="34" charset="0"/>
+                <a:ea typeface="Arial" pitchFamily="34" charset="-122"/>
+                <a:cs typeface="Arial" pitchFamily="34" charset="-120"/>
+              </a:rPr>
+              <a:t>已铸造</a:t>
+            </a:r>
+            <a:endParaRPr lang="en-US" sz="2000" dirty="0"/>
+          </a:p>
+        </p:txBody>
+      </p:sp>
+      <p:sp>
+        <p:nvSpPr>
+          <p:cNvPr id="7" name="Shape 4"/>
+          <p:cNvSpPr/>
+          <p:nvPr/>
+        </p:nvSpPr>
+        <p:spPr>
+          <a:xfrm>
+            <a:off x="6583680" y="1097280"/>
+            <a:ext cx="2286000" cy="3566160"/>
+          </a:xfrm>
+          <a:prstGeom prst="rect">
+            <a:avLst/>
+          </a:prstGeom>
+          <a:solidFill>
+            <a:srgbClr val="1A1F3A"/>
+          </a:solidFill>
+          <a:ln w="12700">
+            <a:solidFill>
+              <a:srgbClr val="4A90D9"/>
+            </a:solidFill>
+            <a:prstDash val="solid"/>
+          </a:ln>
+        </p:spPr>
+      </p:sp>
+      <p:sp>
+        <p:nvSpPr>
+          <p:cNvPr id="8" name="Text 5"/>
+          <p:cNvSpPr/>
+          <p:nvPr/>
+        </p:nvSpPr>
+        <p:spPr>
+          <a:xfrm>
+            <a:off x="6766560" y="1371600"/>
+            <a:ext cx="1920240" cy="2926080"/>
+          </a:xfrm>
+          <a:prstGeom prst="rect">
+            <a:avLst/>
+          </a:prstGeom>
+          <a:noFill/>
+          <a:ln/>
+        </p:spPr>
+        <p:txBody>
+          <a:bodyPr wrap="square" rtlCol="0" anchor="t"/>
+          <a:lstStyle/>
+          <a:p>
+            <a:pPr algn="ctr" indent="0" marL="0">
               <a:buNone/>
             </a:pPr>
             <a:r>
               <a:rPr lang="en-US" sz="1400" b="1" dirty="0">
                 <a:solidFill>
-                  <a:srgbClr val="888888"/>
+                  <a:srgbClr val="4A90D9"/>
                 </a:solidFill>
                 <a:latin typeface="Consolas" pitchFamily="34" charset="0"/>
                 <a:ea typeface="Consolas" pitchFamily="34" charset="-122"/>
                 <a:cs typeface="Consolas" pitchFamily="34" charset="-120"/>
               </a:rPr>
-              <a:t>uPEG 启发 Seed-based Generative 雅典娜</a:t>
+              <a:t>Sepolia</a:t>
             </a:r>
             <a:endParaRPr lang="en-US" sz="1400" dirty="0"/>
           </a:p>
           <a:p>
-            <a:pPr algn="l" indent="0" marL="0">
+            <a:pPr algn="ctr" indent="0" marL="0">
               <a:buNone/>
             </a:pPr>
             <a:endParaRPr lang="en-US" sz="1400" dirty="0"/>
           </a:p>
           <a:p>
-            <a:pPr algn="l" indent="0" marL="0">
-              <a:buNone/>
-            </a:pPr>
-            <a:r>
-              <a:rPr lang="en-US" sz="1400" dirty="0">
+            <a:pPr algn="ctr" indent="0" marL="0">
+              <a:buNone/>
+            </a:pPr>
+            <a:r>
+              <a:rPr lang="en-US" sz="1000" dirty="0">
                 <a:solidFill>
                   <a:srgbClr val="888888"/>
                 </a:solidFill>
@@ -5201,16 +5535,16 @@
                 <a:ea typeface="Consolas" pitchFamily="34" charset="-122"/>
                 <a:cs typeface="Consolas" pitchFamily="34" charset="-120"/>
               </a:rPr>
-              <a:t>• uint256 18-bit seed → 9 traits x 2 bits</a:t>
+              <a:t>ERC-1155</a:t>
             </a:r>
             <a:endParaRPr lang="en-US" sz="1400" dirty="0"/>
           </a:p>
           <a:p>
-            <a:pPr algn="l" indent="0" marL="0">
-              <a:buNone/>
-            </a:pPr>
-            <a:r>
-              <a:rPr lang="en-US" sz="1400" dirty="0">
+            <a:pPr algn="ctr" indent="0" marL="0">
+              <a:buNone/>
+            </a:pPr>
+            <a:r>
+              <a:rPr lang="en-US" sz="1000" dirty="0">
                 <a:solidFill>
                   <a:srgbClr val="888888"/>
                 </a:solidFill>
@@ -5218,16 +5552,16 @@
                 <a:ea typeface="Consolas" pitchFamily="34" charset="-122"/>
                 <a:cs typeface="Consolas" pitchFamily="34" charset="-120"/>
               </a:rPr>
-              <a:t>• 4^9 = 262,144 种组合</a:t>
+              <a:t>ERC-20 ART</a:t>
             </a:r>
             <a:endParaRPr lang="en-US" sz="1400" dirty="0"/>
           </a:p>
           <a:p>
-            <a:pPr algn="l" indent="0" marL="0">
-              <a:buNone/>
-            </a:pPr>
-            <a:r>
-              <a:rPr lang="en-US" sz="1400" dirty="0">
+            <a:pPr algn="ctr" indent="0" marL="0">
+              <a:buNone/>
+            </a:pPr>
+            <a:r>
+              <a:rPr lang="en-US" sz="1000" dirty="0">
                 <a:solidFill>
                   <a:srgbClr val="888888"/>
                 </a:solidFill>
@@ -5235,16 +5569,22 @@
                 <a:ea typeface="Consolas" pitchFamily="34" charset="-122"/>
                 <a:cs typeface="Consolas" pitchFamily="34" charset="-120"/>
               </a:rPr>
-              <a:t>• S/A/B/C 四级稀有度</a:t>
+              <a:t>EAS 认证</a:t>
             </a:r>
             <a:endParaRPr lang="en-US" sz="1400" dirty="0"/>
           </a:p>
           <a:p>
-            <a:pPr algn="l" indent="0" marL="0">
-              <a:buNone/>
-            </a:pPr>
-            <a:r>
-              <a:rPr lang="en-US" sz="1400" dirty="0">
+            <a:pPr algn="ctr" indent="0" marL="0">
+              <a:buNone/>
+            </a:pPr>
+            <a:endParaRPr lang="en-US" sz="1400" dirty="0"/>
+          </a:p>
+          <a:p>
+            <a:pPr algn="ctr" indent="0" marL="0">
+              <a:buNone/>
+            </a:pPr>
+            <a:r>
+              <a:rPr lang="en-US" sz="800" dirty="0">
                 <a:solidFill>
                   <a:srgbClr val="888888"/>
                 </a:solidFill>
@@ -5252,16 +5592,16 @@
                 <a:ea typeface="Consolas" pitchFamily="34" charset="-122"/>
                 <a:cs typeface="Consolas" pitchFamily="34" charset="-120"/>
               </a:rPr>
-              <a:t>• 动态稀有度：OpenRarity 算法</a:t>
+              <a:t>0x3247...</a:t>
             </a:r>
             <a:endParaRPr lang="en-US" sz="1400" dirty="0"/>
           </a:p>
           <a:p>
-            <a:pPr algn="l" indent="0" marL="0">
-              <a:buNone/>
-            </a:pPr>
-            <a:r>
-              <a:rPr lang="en-US" sz="1400" dirty="0">
+            <a:pPr algn="ctr" indent="0" marL="0">
+              <a:buNone/>
+            </a:pPr>
+            <a:r>
+              <a:rPr lang="en-US" sz="800" dirty="0">
                 <a:solidFill>
                   <a:srgbClr val="888888"/>
                 </a:solidFill>
@@ -5269,72 +5609,15 @@
                 <a:ea typeface="Consolas" pitchFamily="34" charset="-122"/>
                 <a:cs typeface="Consolas" pitchFamily="34" charset="-120"/>
               </a:rPr>
-              <a:t>• SVG 缓存机制：减少 gas</a:t>
+              <a:t>d57d37bd</a:t>
             </a:r>
             <a:endParaRPr lang="en-US" sz="1400" dirty="0"/>
           </a:p>
-          <a:p>
-            <a:pPr algn="l" indent="0" marL="0">
-              <a:buNone/>
-            </a:pPr>
-            <a:r>
-              <a:rPr lang="en-US" sz="1400" dirty="0">
-                <a:solidFill>
-                  <a:srgbClr val="888888"/>
-                </a:solidFill>
-                <a:latin typeface="Consolas" pitchFamily="34" charset="0"/>
-                <a:ea typeface="Consolas" pitchFamily="34" charset="-122"/>
-                <a:cs typeface="Consolas" pitchFamily="34" charset="-120"/>
-              </a:rPr>
-              <a:t>• ART 声誉代币（ERC-20）：1000 ART = 1 NFT</a:t>
-            </a:r>
-            <a:endParaRPr lang="en-US" sz="1400" dirty="0"/>
-          </a:p>
-          <a:p>
-            <a:pPr algn="l" indent="0" marL="0">
-              <a:buNone/>
-            </a:pPr>
-            <a:endParaRPr lang="en-US" sz="1400" dirty="0"/>
-          </a:p>
-          <a:p>
-            <a:pPr algn="l" indent="0" marL="0">
-              <a:buNone/>
-            </a:pPr>
-            <a:r>
-              <a:rPr lang="en-US" sz="1400" dirty="0">
-                <a:solidFill>
-                  <a:srgbClr val="888888"/>
-                </a:solidFill>
-                <a:latin typeface="Consolas" pitchFamily="34" charset="0"/>
-                <a:ea typeface="Consolas" pitchFamily="34" charset="-122"/>
-                <a:cs typeface="Consolas" pitchFamily="34" charset="-120"/>
-              </a:rPr>
-              <a:t>Sepolia: 0x4F541D6f6249deAE5cDa2B00625d6933E4943b3c</a:t>
-            </a:r>
-            <a:endParaRPr lang="en-US" sz="1400" dirty="0"/>
-          </a:p>
-          <a:p>
-            <a:pPr algn="l" indent="0" marL="0">
-              <a:buNone/>
-            </a:pPr>
-            <a:r>
-              <a:rPr lang="en-US" sz="1400" dirty="0">
-                <a:solidFill>
-                  <a:srgbClr val="888888"/>
-                </a:solidFill>
-                <a:latin typeface="Consolas" pitchFamily="34" charset="0"/>
-                <a:ea typeface="Consolas" pitchFamily="34" charset="-122"/>
-                <a:cs typeface="Consolas" pitchFamily="34" charset="-120"/>
-              </a:rPr>
-              <a:t>EAS + ERC-1155 + ERC-20</a:t>
-            </a:r>
-            <a:endParaRPr lang="en-US" sz="1400" dirty="0"/>
-          </a:p>
-        </p:txBody>
-      </p:sp>
-      <p:sp>
-        <p:nvSpPr>
-          <p:cNvPr id="5" name="Text 3"/>
+        </p:txBody>
+      </p:sp>
+      <p:sp>
+        <p:nvSpPr>
+          <p:cNvPr id="9" name="Text 6"/>
           <p:cNvSpPr/>
           <p:nvPr/>
         </p:nvSpPr>

</xml_diff>

<commit_message>
fix: all 5 SVGs now embedded in PPT (moved slide creation inside async IIFE)
- architecture.svg → Slide 4
- skill-agents.svg → Slide 5
- mcp-tools.svg → Slide 6
- audit-report.svg → Slide 7
- onchain-verification.svg → Slide 7
- 3.1MB PPTX, no more addImage errors
</commit_message>
<xml_diff>
--- a/ppt-assets/Athena-Hackathon.pptx
+++ b/ppt-assets/Athena-Hackathon.pptx
@@ -3073,12 +3073,20 @@
           </a:p>
         </p:txBody>
       </p:sp>
-      <p:sp>
-        <p:nvSpPr>
-          <p:cNvPr id="3" name="Shape 1"/>
-          <p:cNvSpPr/>
-          <p:nvPr/>
-        </p:nvSpPr>
+      <p:pic>
+        <p:nvPicPr>
+          <p:cNvPr id="3" name="Image 0" descr="/root/projects/glm-code/ppt-assets/architecture.png">    </p:cNvPr>
+          <p:cNvPicPr>
+            <a:picLocks noChangeAspect="1"/>
+          </p:cNvPicPr>
+          <p:nvPr/>
+        </p:nvPicPr>
+        <p:blipFill>
+          <a:blip r:embed="rId1"/>
+          <a:stretch>
+            <a:fillRect/>
+          </a:stretch>
+        </p:blipFill>
         <p:spPr>
           <a:xfrm>
             <a:off x="457200" y="1097280"/>
@@ -3087,161 +3095,11 @@
           <a:prstGeom prst="rect">
             <a:avLst/>
           </a:prstGeom>
-          <a:solidFill>
-            <a:srgbClr val="1A1F3A"/>
-          </a:solidFill>
-          <a:ln w="12700">
-            <a:solidFill>
-              <a:srgbClr val="4A90D9"/>
-            </a:solidFill>
-            <a:prstDash val="solid"/>
-          </a:ln>
-        </p:spPr>
-      </p:sp>
-      <p:sp>
-        <p:nvSpPr>
-          <p:cNvPr id="4" name="Text 2"/>
-          <p:cNvSpPr/>
-          <p:nvPr/>
-        </p:nvSpPr>
-        <p:spPr>
-          <a:xfrm>
-            <a:off x="914400" y="1371600"/>
-            <a:ext cx="7315200" cy="2926080"/>
-          </a:xfrm>
-          <a:prstGeom prst="rect">
-            <a:avLst/>
-          </a:prstGeom>
-          <a:noFill/>
-          <a:ln/>
-        </p:spPr>
-        <p:txBody>
-          <a:bodyPr wrap="square" rtlCol="0" anchor="ctr"/>
-          <a:lstStyle/>
-          <a:p>
-            <a:pPr algn="ctr" indent="0" marL="0">
-              <a:buNone/>
-            </a:pPr>
-            <a:r>
-              <a:rPr lang="en-US" sz="1600" dirty="0">
-                <a:solidFill>
-                  <a:srgbClr val="FFFFFF"/>
-                </a:solidFill>
-                <a:latin typeface="Consolas" pitchFamily="34" charset="0"/>
-                <a:ea typeface="Consolas" pitchFamily="34" charset="-122"/>
-                <a:cs typeface="Consolas" pitchFamily="34" charset="-120"/>
-              </a:rPr>
-              <a:t>GLM-5.1 推理引擎（中央协调）</a:t>
-            </a:r>
-            <a:endParaRPr lang="en-US" sz="1600" dirty="0"/>
-          </a:p>
-          <a:p>
-            <a:pPr algn="ctr" indent="0" marL="0">
-              <a:buNone/>
-            </a:pPr>
-            <a:r>
-              <a:rPr lang="en-US" sz="1600" dirty="0">
-                <a:solidFill>
-                  <a:srgbClr val="FFFFFF"/>
-                </a:solidFill>
-                <a:latin typeface="Consolas" pitchFamily="34" charset="0"/>
-                <a:ea typeface="Consolas" pitchFamily="34" charset="-122"/>
-                <a:cs typeface="Consolas" pitchFamily="34" charset="-120"/>
-              </a:rPr>
-              <a:t>↓</a:t>
-            </a:r>
-            <a:endParaRPr lang="en-US" sz="1600" dirty="0"/>
-          </a:p>
-          <a:p>
-            <a:pPr algn="ctr" indent="0" marL="0">
-              <a:buNone/>
-            </a:pPr>
-            <a:r>
-              <a:rPr lang="en-US" sz="1600" dirty="0">
-                <a:solidFill>
-                  <a:srgbClr val="FFFFFF"/>
-                </a:solidFill>
-                <a:latin typeface="Consolas" pitchFamily="34" charset="0"/>
-                <a:ea typeface="Consolas" pitchFamily="34" charset="-122"/>
-                <a:cs typeface="Consolas" pitchFamily="34" charset="-120"/>
-              </a:rPr>
-              <a:t>12 Agent 审计 Skill（并行执行）</a:t>
-            </a:r>
-            <a:endParaRPr lang="en-US" sz="1600" dirty="0"/>
-          </a:p>
-          <a:p>
-            <a:pPr algn="ctr" indent="0" marL="0">
-              <a:buNone/>
-            </a:pPr>
-            <a:r>
-              <a:rPr lang="en-US" sz="1600" dirty="0">
-                <a:solidFill>
-                  <a:srgbClr val="FFFFFF"/>
-                </a:solidFill>
-                <a:latin typeface="Consolas" pitchFamily="34" charset="0"/>
-                <a:ea typeface="Consolas" pitchFamily="34" charset="-122"/>
-                <a:cs typeface="Consolas" pitchFamily="34" charset="-120"/>
-              </a:rPr>
-              <a:t>↓</a:t>
-            </a:r>
-            <a:endParaRPr lang="en-US" sz="1600" dirty="0"/>
-          </a:p>
-          <a:p>
-            <a:pPr algn="ctr" indent="0" marL="0">
-              <a:buNone/>
-            </a:pPr>
-            <a:r>
-              <a:rPr lang="en-US" sz="1600" dirty="0">
-                <a:solidFill>
-                  <a:srgbClr val="FFFFFF"/>
-                </a:solidFill>
-                <a:latin typeface="Consolas" pitchFamily="34" charset="0"/>
-                <a:ea typeface="Consolas" pitchFamily="34" charset="-122"/>
-                <a:cs typeface="Consolas" pitchFamily="34" charset="-120"/>
-              </a:rPr>
-              <a:t>13 MCP 工具（链上+链下）</a:t>
-            </a:r>
-            <a:endParaRPr lang="en-US" sz="1600" dirty="0"/>
-          </a:p>
-          <a:p>
-            <a:pPr algn="ctr" indent="0" marL="0">
-              <a:buNone/>
-            </a:pPr>
-            <a:r>
-              <a:rPr lang="en-US" sz="1600" dirty="0">
-                <a:solidFill>
-                  <a:srgbClr val="FFFFFF"/>
-                </a:solidFill>
-                <a:latin typeface="Consolas" pitchFamily="34" charset="0"/>
-                <a:ea typeface="Consolas" pitchFamily="34" charset="-122"/>
-                <a:cs typeface="Consolas" pitchFamily="34" charset="-120"/>
-              </a:rPr>
-              <a:t>↓</a:t>
-            </a:r>
-            <a:endParaRPr lang="en-US" sz="1600" dirty="0"/>
-          </a:p>
-          <a:p>
-            <a:pPr algn="ctr" indent="0" marL="0">
-              <a:buNone/>
-            </a:pPr>
-            <a:r>
-              <a:rPr lang="en-US" sz="1600" dirty="0">
-                <a:solidFill>
-                  <a:srgbClr val="FFFFFF"/>
-                </a:solidFill>
-                <a:latin typeface="Consolas" pitchFamily="34" charset="0"/>
-                <a:ea typeface="Consolas" pitchFamily="34" charset="-122"/>
-                <a:cs typeface="Consolas" pitchFamily="34" charset="-120"/>
-              </a:rPr>
-              <a:t>Sepolia 测试网（零成本验证）</a:t>
-            </a:r>
-            <a:endParaRPr lang="en-US" sz="1600" dirty="0"/>
-          </a:p>
-        </p:txBody>
-      </p:sp>
-      <p:sp>
-        <p:nvSpPr>
-          <p:cNvPr id="5" name="Text 3"/>
+        </p:spPr>
+      </p:pic>
+      <p:sp>
+        <p:nvSpPr>
+          <p:cNvPr id="4" name="Text 1"/>
           <p:cNvSpPr/>
           <p:nvPr/>
         </p:nvSpPr>
@@ -3346,510 +3204,33 @@
           </a:p>
         </p:txBody>
       </p:sp>
-      <p:sp>
-        <p:nvSpPr>
-          <p:cNvPr id="3" name="Shape 1"/>
-          <p:cNvSpPr/>
-          <p:nvPr/>
-        </p:nvSpPr>
-        <p:spPr>
-          <a:xfrm>
-            <a:off x="457200" y="1188720"/>
-            <a:ext cx="2560320" cy="3200400"/>
-          </a:xfrm>
-          <a:prstGeom prst="rect">
-            <a:avLst/>
-          </a:prstGeom>
-          <a:solidFill>
-            <a:srgbClr val="1A1F3A"/>
-          </a:solidFill>
-          <a:ln w="12700">
-            <a:solidFill>
-              <a:srgbClr val="4A90D9"/>
-            </a:solidFill>
-            <a:prstDash val="solid"/>
-          </a:ln>
-        </p:spPr>
-      </p:sp>
-      <p:sp>
-        <p:nvSpPr>
-          <p:cNvPr id="4" name="Text 2"/>
-          <p:cNvSpPr/>
-          <p:nvPr/>
-        </p:nvSpPr>
-        <p:spPr>
-          <a:xfrm>
-            <a:off x="548640" y="1280160"/>
-            <a:ext cx="2377440" cy="457200"/>
-          </a:xfrm>
-          <a:prstGeom prst="rect">
-            <a:avLst/>
-          </a:prstGeom>
-          <a:noFill/>
-          <a:ln/>
-        </p:spPr>
-        <p:txBody>
-          <a:bodyPr wrap="square" rtlCol="0" anchor="ctr"/>
-          <a:lstStyle/>
-          <a:p>
-            <a:pPr algn="ctr" indent="0" marL="0">
-              <a:buNone/>
-            </a:pPr>
-            <a:r>
-              <a:rPr lang="en-US" sz="1400" b="1" dirty="0">
-                <a:solidFill>
-                  <a:srgbClr val="4A90D9"/>
-                </a:solidFill>
-                <a:latin typeface="Arial" pitchFamily="34" charset="0"/>
-                <a:ea typeface="Arial" pitchFamily="34" charset="-122"/>
-                <a:cs typeface="Arial" pitchFamily="34" charset="-120"/>
-              </a:rPr>
-              <a:t>基础分析</a:t>
-            </a:r>
-            <a:endParaRPr lang="en-US" sz="1400" dirty="0"/>
-          </a:p>
-        </p:txBody>
-      </p:sp>
-      <p:sp>
-        <p:nvSpPr>
-          <p:cNvPr id="5" name="Text 3"/>
-          <p:cNvSpPr/>
-          <p:nvPr/>
-        </p:nvSpPr>
-        <p:spPr>
-          <a:xfrm>
-            <a:off x="640080" y="1828800"/>
-            <a:ext cx="2194560" cy="2286000"/>
-          </a:xfrm>
-          <a:prstGeom prst="rect">
-            <a:avLst/>
-          </a:prstGeom>
-          <a:noFill/>
-          <a:ln/>
-        </p:spPr>
-        <p:txBody>
-          <a:bodyPr wrap="square" rtlCol="0" anchor="t"/>
-          <a:lstStyle/>
-          <a:p>
-            <a:pPr algn="l" indent="0" marL="0">
-              <a:buNone/>
-            </a:pPr>
-            <a:r>
-              <a:rPr lang="en-US" sz="1200" dirty="0">
-                <a:solidFill>
-                  <a:srgbClr val="888888"/>
-                </a:solidFill>
-                <a:latin typeface="Arial" pitchFamily="34" charset="0"/>
-                <a:ea typeface="Arial" pitchFamily="34" charset="-122"/>
-                <a:cs typeface="Arial" pitchFamily="34" charset="-120"/>
-              </a:rPr>
-              <a:t>• Scope</a:t>
-            </a:r>
-            <a:endParaRPr lang="en-US" sz="1200" dirty="0"/>
-          </a:p>
-          <a:p>
-            <a:pPr algn="l" indent="0" marL="0">
-              <a:buNone/>
-            </a:pPr>
-            <a:r>
-              <a:rPr lang="en-US" sz="1200" dirty="0">
-                <a:solidFill>
-                  <a:srgbClr val="888888"/>
-                </a:solidFill>
-                <a:latin typeface="Arial" pitchFamily="34" charset="0"/>
-                <a:ea typeface="Arial" pitchFamily="34" charset="-122"/>
-                <a:cs typeface="Arial" pitchFamily="34" charset="-120"/>
-              </a:rPr>
-              <a:t>• Architecture</a:t>
-            </a:r>
-            <a:endParaRPr lang="en-US" sz="1200" dirty="0"/>
-          </a:p>
-          <a:p>
-            <a:pPr algn="l" indent="0" marL="0">
-              <a:buNone/>
-            </a:pPr>
-            <a:r>
-              <a:rPr lang="en-US" sz="1200" dirty="0">
-                <a:solidFill>
-                  <a:srgbClr val="888888"/>
-                </a:solidFill>
-                <a:latin typeface="Arial" pitchFamily="34" charset="0"/>
-                <a:ea typeface="Arial" pitchFamily="34" charset="-122"/>
-                <a:cs typeface="Arial" pitchFamily="34" charset="-120"/>
-              </a:rPr>
-              <a:t>• Access Control</a:t>
-            </a:r>
-            <a:endParaRPr lang="en-US" sz="1200" dirty="0"/>
-          </a:p>
-          <a:p>
-            <a:pPr algn="l" indent="0" marL="0">
-              <a:buNone/>
-            </a:pPr>
-            <a:r>
-              <a:rPr lang="en-US" sz="1200" dirty="0">
-                <a:solidFill>
-                  <a:srgbClr val="888888"/>
-                </a:solidFill>
-                <a:latin typeface="Arial" pitchFamily="34" charset="0"/>
-                <a:ea typeface="Arial" pitchFamily="34" charset="-122"/>
-                <a:cs typeface="Arial" pitchFamily="34" charset="-120"/>
-              </a:rPr>
-              <a:t>• Math</a:t>
-            </a:r>
-            <a:endParaRPr lang="en-US" sz="1200" dirty="0"/>
-          </a:p>
-        </p:txBody>
-      </p:sp>
-      <p:sp>
-        <p:nvSpPr>
-          <p:cNvPr id="6" name="Shape 4"/>
-          <p:cNvSpPr/>
-          <p:nvPr/>
-        </p:nvSpPr>
-        <p:spPr>
-          <a:xfrm>
-            <a:off x="3291840" y="1188720"/>
-            <a:ext cx="2560320" cy="3200400"/>
-          </a:xfrm>
-          <a:prstGeom prst="rect">
-            <a:avLst/>
-          </a:prstGeom>
-          <a:solidFill>
-            <a:srgbClr val="1A1F3A"/>
-          </a:solidFill>
-          <a:ln w="12700">
-            <a:solidFill>
-              <a:srgbClr val="4A90D9"/>
-            </a:solidFill>
-            <a:prstDash val="solid"/>
-          </a:ln>
-        </p:spPr>
-      </p:sp>
-      <p:sp>
-        <p:nvSpPr>
-          <p:cNvPr id="7" name="Text 5"/>
-          <p:cNvSpPr/>
-          <p:nvPr/>
-        </p:nvSpPr>
-        <p:spPr>
-          <a:xfrm>
-            <a:off x="3383280" y="1280160"/>
-            <a:ext cx="2377440" cy="457200"/>
-          </a:xfrm>
-          <a:prstGeom prst="rect">
-            <a:avLst/>
-          </a:prstGeom>
-          <a:noFill/>
-          <a:ln/>
-        </p:spPr>
-        <p:txBody>
-          <a:bodyPr wrap="square" rtlCol="0" anchor="ctr"/>
-          <a:lstStyle/>
-          <a:p>
-            <a:pPr algn="ctr" indent="0" marL="0">
-              <a:buNone/>
-            </a:pPr>
-            <a:r>
-              <a:rPr lang="en-US" sz="1400" b="1" dirty="0">
-                <a:solidFill>
-                  <a:srgbClr val="4A90D9"/>
-                </a:solidFill>
-                <a:latin typeface="Arial" pitchFamily="34" charset="0"/>
-                <a:ea typeface="Arial" pitchFamily="34" charset="-122"/>
-                <a:cs typeface="Arial" pitchFamily="34" charset="-120"/>
-              </a:rPr>
-              <a:t>漏洞猎手</a:t>
-            </a:r>
-            <a:endParaRPr lang="en-US" sz="1400" dirty="0"/>
-          </a:p>
-        </p:txBody>
-      </p:sp>
-      <p:sp>
-        <p:nvSpPr>
-          <p:cNvPr id="8" name="Text 6"/>
-          <p:cNvSpPr/>
-          <p:nvPr/>
-        </p:nvSpPr>
-        <p:spPr>
-          <a:xfrm>
-            <a:off x="3474720" y="1828800"/>
-            <a:ext cx="2194560" cy="2286000"/>
-          </a:xfrm>
-          <a:prstGeom prst="rect">
-            <a:avLst/>
-          </a:prstGeom>
-          <a:noFill/>
-          <a:ln/>
-        </p:spPr>
-        <p:txBody>
-          <a:bodyPr wrap="square" rtlCol="0" anchor="t"/>
-          <a:lstStyle/>
-          <a:p>
-            <a:pPr algn="l" indent="0" marL="0">
-              <a:buNone/>
-            </a:pPr>
-            <a:r>
-              <a:rPr lang="en-US" sz="1200" dirty="0">
-                <a:solidFill>
-                  <a:srgbClr val="888888"/>
-                </a:solidFill>
-                <a:latin typeface="Arial" pitchFamily="34" charset="0"/>
-                <a:ea typeface="Arial" pitchFamily="34" charset="-122"/>
-                <a:cs typeface="Arial" pitchFamily="34" charset="-120"/>
-              </a:rPr>
-              <a:t>• Reentrancy</a:t>
-            </a:r>
-            <a:endParaRPr lang="en-US" sz="1200" dirty="0"/>
-          </a:p>
-          <a:p>
-            <a:pPr algn="l" indent="0" marL="0">
-              <a:buNone/>
-            </a:pPr>
-            <a:r>
-              <a:rPr lang="en-US" sz="1200" dirty="0">
-                <a:solidFill>
-                  <a:srgbClr val="888888"/>
-                </a:solidFill>
-                <a:latin typeface="Arial" pitchFamily="34" charset="0"/>
-                <a:ea typeface="Arial" pitchFamily="34" charset="-122"/>
-                <a:cs typeface="Arial" pitchFamily="34" charset="-120"/>
-              </a:rPr>
-              <a:t>• Oracle</a:t>
-            </a:r>
-            <a:endParaRPr lang="en-US" sz="1200" dirty="0"/>
-          </a:p>
-          <a:p>
-            <a:pPr algn="l" indent="0" marL="0">
-              <a:buNone/>
-            </a:pPr>
-            <a:r>
-              <a:rPr lang="en-US" sz="1200" dirty="0">
-                <a:solidFill>
-                  <a:srgbClr val="888888"/>
-                </a:solidFill>
-                <a:latin typeface="Arial" pitchFamily="34" charset="0"/>
-                <a:ea typeface="Arial" pitchFamily="34" charset="-122"/>
-                <a:cs typeface="Arial" pitchFamily="34" charset="-120"/>
-              </a:rPr>
-              <a:t>• Flash Loan</a:t>
-            </a:r>
-            <a:endParaRPr lang="en-US" sz="1200" dirty="0"/>
-          </a:p>
-          <a:p>
-            <a:pPr algn="l" indent="0" marL="0">
-              <a:buNone/>
-            </a:pPr>
-            <a:r>
-              <a:rPr lang="en-US" sz="1200" dirty="0">
-                <a:solidFill>
-                  <a:srgbClr val="888888"/>
-                </a:solidFill>
-                <a:latin typeface="Arial" pitchFamily="34" charset="0"/>
-                <a:ea typeface="Arial" pitchFamily="34" charset="-122"/>
-                <a:cs typeface="Arial" pitchFamily="34" charset="-120"/>
-              </a:rPr>
-              <a:t>• Logic</a:t>
-            </a:r>
-            <a:endParaRPr lang="en-US" sz="1200" dirty="0"/>
-          </a:p>
-        </p:txBody>
-      </p:sp>
-      <p:sp>
-        <p:nvSpPr>
-          <p:cNvPr id="9" name="Shape 7"/>
-          <p:cNvSpPr/>
-          <p:nvPr/>
-        </p:nvSpPr>
-        <p:spPr>
-          <a:xfrm>
-            <a:off x="6126480" y="1188720"/>
-            <a:ext cx="2560320" cy="3200400"/>
-          </a:xfrm>
-          <a:prstGeom prst="rect">
-            <a:avLst/>
-          </a:prstGeom>
-          <a:solidFill>
-            <a:srgbClr val="1A1F3A"/>
-          </a:solidFill>
-          <a:ln w="12700">
-            <a:solidFill>
-              <a:srgbClr val="4A90D9"/>
-            </a:solidFill>
-            <a:prstDash val="solid"/>
-          </a:ln>
-        </p:spPr>
-      </p:sp>
-      <p:sp>
-        <p:nvSpPr>
-          <p:cNvPr id="10" name="Text 8"/>
-          <p:cNvSpPr/>
-          <p:nvPr/>
-        </p:nvSpPr>
-        <p:spPr>
-          <a:xfrm>
-            <a:off x="6217920" y="1280160"/>
-            <a:ext cx="2377440" cy="457200"/>
-          </a:xfrm>
-          <a:prstGeom prst="rect">
-            <a:avLst/>
-          </a:prstGeom>
-          <a:noFill/>
-          <a:ln/>
-        </p:spPr>
-        <p:txBody>
-          <a:bodyPr wrap="square" rtlCol="0" anchor="ctr"/>
-          <a:lstStyle/>
-          <a:p>
-            <a:pPr algn="ctr" indent="0" marL="0">
-              <a:buNone/>
-            </a:pPr>
-            <a:r>
-              <a:rPr lang="en-US" sz="1400" b="1" dirty="0">
-                <a:solidFill>
-                  <a:srgbClr val="4A90D9"/>
-                </a:solidFill>
-                <a:latin typeface="Arial" pitchFamily="34" charset="0"/>
-                <a:ea typeface="Arial" pitchFamily="34" charset="-122"/>
-                <a:cs typeface="Arial" pitchFamily="34" charset="-120"/>
-              </a:rPr>
-              <a:t>辅助/输出</a:t>
-            </a:r>
-            <a:endParaRPr lang="en-US" sz="1400" dirty="0"/>
-          </a:p>
-        </p:txBody>
-      </p:sp>
-      <p:sp>
-        <p:nvSpPr>
-          <p:cNvPr id="11" name="Text 9"/>
-          <p:cNvSpPr/>
-          <p:nvPr/>
-        </p:nvSpPr>
-        <p:spPr>
-          <a:xfrm>
-            <a:off x="6309360" y="1828800"/>
-            <a:ext cx="2194560" cy="2286000"/>
-          </a:xfrm>
-          <a:prstGeom prst="rect">
-            <a:avLst/>
-          </a:prstGeom>
-          <a:noFill/>
-          <a:ln/>
-        </p:spPr>
-        <p:txBody>
-          <a:bodyPr wrap="square" rtlCol="0" anchor="t"/>
-          <a:lstStyle/>
-          <a:p>
-            <a:pPr algn="l" indent="0" marL="0">
-              <a:buNone/>
-            </a:pPr>
-            <a:r>
-              <a:rPr lang="en-US" sz="1200" dirty="0">
-                <a:solidFill>
-                  <a:srgbClr val="888888"/>
-                </a:solidFill>
-                <a:latin typeface="Arial" pitchFamily="34" charset="0"/>
-                <a:ea typeface="Arial" pitchFamily="34" charset="-122"/>
-                <a:cs typeface="Arial" pitchFamily="34" charset="-120"/>
-              </a:rPr>
-              <a:t>• Gas</a:t>
-            </a:r>
-            <a:endParaRPr lang="en-US" sz="1200" dirty="0"/>
-          </a:p>
-          <a:p>
-            <a:pPr algn="l" indent="0" marL="0">
-              <a:buNone/>
-            </a:pPr>
-            <a:r>
-              <a:rPr lang="en-US" sz="1200" dirty="0">
-                <a:solidFill>
-                  <a:srgbClr val="888888"/>
-                </a:solidFill>
-                <a:latin typeface="Arial" pitchFamily="34" charset="0"/>
-                <a:ea typeface="Arial" pitchFamily="34" charset="-122"/>
-                <a:cs typeface="Arial" pitchFamily="34" charset="-120"/>
-              </a:rPr>
-              <a:t>• Frontend</a:t>
-            </a:r>
-            <a:endParaRPr lang="en-US" sz="1200" dirty="0"/>
-          </a:p>
-          <a:p>
-            <a:pPr algn="l" indent="0" marL="0">
-              <a:buNone/>
-            </a:pPr>
-            <a:r>
-              <a:rPr lang="en-US" sz="1200" dirty="0">
-                <a:solidFill>
-                  <a:srgbClr val="888888"/>
-                </a:solidFill>
-                <a:latin typeface="Arial" pitchFamily="34" charset="0"/>
-                <a:ea typeface="Arial" pitchFamily="34" charset="-122"/>
-                <a:cs typeface="Arial" pitchFamily="34" charset="-120"/>
-              </a:rPr>
-              <a:t>• PoC</a:t>
-            </a:r>
-            <a:endParaRPr lang="en-US" sz="1200" dirty="0"/>
-          </a:p>
-          <a:p>
-            <a:pPr algn="l" indent="0" marL="0">
-              <a:buNone/>
-            </a:pPr>
-            <a:r>
-              <a:rPr lang="en-US" sz="1200" dirty="0">
-                <a:solidFill>
-                  <a:srgbClr val="888888"/>
-                </a:solidFill>
-                <a:latin typeface="Arial" pitchFamily="34" charset="0"/>
-                <a:ea typeface="Arial" pitchFamily="34" charset="-122"/>
-                <a:cs typeface="Arial" pitchFamily="34" charset="-120"/>
-              </a:rPr>
-              <a:t>• Report</a:t>
-            </a:r>
-            <a:endParaRPr lang="en-US" sz="1200" dirty="0"/>
-          </a:p>
-        </p:txBody>
-      </p:sp>
-      <p:sp>
-        <p:nvSpPr>
-          <p:cNvPr id="12" name="Text 10"/>
-          <p:cNvSpPr/>
-          <p:nvPr/>
-        </p:nvSpPr>
-        <p:spPr>
-          <a:xfrm>
-            <a:off x="457200" y="4480560"/>
-            <a:ext cx="8229600" cy="365760"/>
-          </a:xfrm>
-          <a:prstGeom prst="rect">
-            <a:avLst/>
-          </a:prstGeom>
-          <a:noFill/>
-          <a:ln/>
-        </p:spPr>
-        <p:txBody>
-          <a:bodyPr wrap="square" rtlCol="0" anchor="ctr"/>
-          <a:lstStyle/>
-          <a:p>
-            <a:pPr algn="ctr" indent="0" marL="0">
-              <a:buNone/>
-            </a:pPr>
-            <a:r>
-              <a:rPr lang="en-US" sz="1200" dirty="0">
-                <a:solidFill>
-                  <a:srgbClr val="888888"/>
-                </a:solidFill>
-                <a:latin typeface="Arial" pitchFamily="34" charset="0"/>
-                <a:ea typeface="Arial" pitchFamily="34" charset="-122"/>
-                <a:cs typeface="Arial" pitchFamily="34" charset="-120"/>
-              </a:rPr>
-              <a:t>10 轮检查流程，GLM-5.1 协调</a:t>
-            </a:r>
-            <a:endParaRPr lang="en-US" sz="1200" dirty="0"/>
-          </a:p>
-        </p:txBody>
-      </p:sp>
-      <p:sp>
-        <p:nvSpPr>
-          <p:cNvPr id="13" name="Text 11"/>
+      <p:pic>
+        <p:nvPicPr>
+          <p:cNvPr id="3" name="Image 0" descr="/root/projects/glm-code/ppt-assets/skill-agents.png">    </p:cNvPr>
+          <p:cNvPicPr>
+            <a:picLocks noChangeAspect="1"/>
+          </p:cNvPicPr>
+          <p:nvPr/>
+        </p:nvPicPr>
+        <p:blipFill>
+          <a:blip r:embed="rId1"/>
+          <a:stretch>
+            <a:fillRect/>
+          </a:stretch>
+        </p:blipFill>
+        <p:spPr>
+          <a:xfrm>
+            <a:off x="457200" y="1097280"/>
+            <a:ext cx="8229600" cy="3474720"/>
+          </a:xfrm>
+          <a:prstGeom prst="rect">
+            <a:avLst/>
+          </a:prstGeom>
+        </p:spPr>
+      </p:pic>
+      <p:sp>
+        <p:nvSpPr>
+          <p:cNvPr id="4" name="Text 1"/>
           <p:cNvSpPr/>
           <p:nvPr/>
         </p:nvSpPr>
@@ -3954,574 +3335,33 @@
           </a:p>
         </p:txBody>
       </p:sp>
-      <p:sp>
-        <p:nvSpPr>
-          <p:cNvPr id="3" name="Shape 1"/>
-          <p:cNvSpPr/>
-          <p:nvPr/>
-        </p:nvSpPr>
-        <p:spPr>
-          <a:xfrm>
-            <a:off x="457200" y="1188720"/>
-            <a:ext cx="1965960" cy="3200400"/>
-          </a:xfrm>
-          <a:prstGeom prst="rect">
-            <a:avLst/>
-          </a:prstGeom>
-          <a:solidFill>
-            <a:srgbClr val="1A1F3A"/>
-          </a:solidFill>
-          <a:ln w="12700">
-            <a:solidFill>
-              <a:srgbClr val="4A90D9"/>
-            </a:solidFill>
-            <a:prstDash val="solid"/>
-          </a:ln>
-        </p:spPr>
-      </p:sp>
-      <p:sp>
-        <p:nvSpPr>
-          <p:cNvPr id="4" name="Text 2"/>
-          <p:cNvSpPr/>
-          <p:nvPr/>
-        </p:nvSpPr>
-        <p:spPr>
-          <a:xfrm>
-            <a:off x="548640" y="1280160"/>
-            <a:ext cx="1783080" cy="457200"/>
-          </a:xfrm>
-          <a:prstGeom prst="rect">
-            <a:avLst/>
-          </a:prstGeom>
-          <a:noFill/>
-          <a:ln/>
-        </p:spPr>
-        <p:txBody>
-          <a:bodyPr wrap="square" rtlCol="0" anchor="ctr"/>
-          <a:lstStyle/>
-          <a:p>
-            <a:pPr algn="ctr" indent="0" marL="0">
-              <a:buNone/>
-            </a:pPr>
-            <a:r>
-              <a:rPr lang="en-US" sz="1200" b="1" dirty="0">
-                <a:solidFill>
-                  <a:srgbClr val="4A90D9"/>
-                </a:solidFill>
-                <a:latin typeface="Arial" pitchFamily="34" charset="0"/>
-                <a:ea typeface="Arial" pitchFamily="34" charset="-122"/>
-                <a:cs typeface="Arial" pitchFamily="34" charset="-120"/>
-              </a:rPr>
-              <a:t>静态分析</a:t>
-            </a:r>
-            <a:endParaRPr lang="en-US" sz="1200" dirty="0"/>
-          </a:p>
-        </p:txBody>
-      </p:sp>
-      <p:sp>
-        <p:nvSpPr>
-          <p:cNvPr id="5" name="Text 3"/>
-          <p:cNvSpPr/>
-          <p:nvPr/>
-        </p:nvSpPr>
-        <p:spPr>
-          <a:xfrm>
-            <a:off x="548640" y="1828800"/>
-            <a:ext cx="1783080" cy="2286000"/>
-          </a:xfrm>
-          <a:prstGeom prst="rect">
-            <a:avLst/>
-          </a:prstGeom>
-          <a:noFill/>
-          <a:ln/>
-        </p:spPr>
-        <p:txBody>
-          <a:bodyPr wrap="square" rtlCol="0" anchor="t"/>
-          <a:lstStyle/>
-          <a:p>
-            <a:pPr algn="l" indent="0" marL="0">
-              <a:buNone/>
-            </a:pPr>
-            <a:r>
-              <a:rPr lang="en-US" sz="1000" dirty="0">
-                <a:solidFill>
-                  <a:srgbClr val="888888"/>
-                </a:solidFill>
-                <a:latin typeface="Arial" pitchFamily="34" charset="0"/>
-                <a:ea typeface="Arial" pitchFamily="34" charset="-122"/>
-                <a:cs typeface="Arial" pitchFamily="34" charset="-120"/>
-              </a:rPr>
-              <a:t>• Slither</a:t>
-            </a:r>
-            <a:endParaRPr lang="en-US" sz="1000" dirty="0"/>
-          </a:p>
-          <a:p>
-            <a:pPr algn="l" indent="0" marL="0">
-              <a:buNone/>
-            </a:pPr>
-            <a:r>
-              <a:rPr lang="en-US" sz="1000" dirty="0">
-                <a:solidFill>
-                  <a:srgbClr val="888888"/>
-                </a:solidFill>
-                <a:latin typeface="Arial" pitchFamily="34" charset="0"/>
-                <a:ea typeface="Arial" pitchFamily="34" charset="-122"/>
-                <a:cs typeface="Arial" pitchFamily="34" charset="-120"/>
-              </a:rPr>
-              <a:t>• Aderyn</a:t>
-            </a:r>
-            <a:endParaRPr lang="en-US" sz="1000" dirty="0"/>
-          </a:p>
-          <a:p>
-            <a:pPr algn="l" indent="0" marL="0">
-              <a:buNone/>
-            </a:pPr>
-            <a:r>
-              <a:rPr lang="en-US" sz="1000" dirty="0">
-                <a:solidFill>
-                  <a:srgbClr val="888888"/>
-                </a:solidFill>
-                <a:latin typeface="Arial" pitchFamily="34" charset="0"/>
-                <a:ea typeface="Arial" pitchFamily="34" charset="-122"/>
-                <a:cs typeface="Arial" pitchFamily="34" charset="-120"/>
-              </a:rPr>
-              <a:t>• Halmos</a:t>
-            </a:r>
-            <a:endParaRPr lang="en-US" sz="1000" dirty="0"/>
-          </a:p>
-        </p:txBody>
-      </p:sp>
-      <p:sp>
-        <p:nvSpPr>
-          <p:cNvPr id="6" name="Shape 4"/>
-          <p:cNvSpPr/>
-          <p:nvPr/>
-        </p:nvSpPr>
-        <p:spPr>
-          <a:xfrm>
-            <a:off x="2606040" y="1188720"/>
-            <a:ext cx="1965960" cy="3200400"/>
-          </a:xfrm>
-          <a:prstGeom prst="rect">
-            <a:avLst/>
-          </a:prstGeom>
-          <a:solidFill>
-            <a:srgbClr val="1A1F3A"/>
-          </a:solidFill>
-          <a:ln w="12700">
-            <a:solidFill>
-              <a:srgbClr val="4A90D9"/>
-            </a:solidFill>
-            <a:prstDash val="solid"/>
-          </a:ln>
-        </p:spPr>
-      </p:sp>
-      <p:sp>
-        <p:nvSpPr>
-          <p:cNvPr id="7" name="Text 5"/>
-          <p:cNvSpPr/>
-          <p:nvPr/>
-        </p:nvSpPr>
-        <p:spPr>
-          <a:xfrm>
-            <a:off x="2697480" y="1280160"/>
-            <a:ext cx="1783080" cy="457200"/>
-          </a:xfrm>
-          <a:prstGeom prst="rect">
-            <a:avLst/>
-          </a:prstGeom>
-          <a:noFill/>
-          <a:ln/>
-        </p:spPr>
-        <p:txBody>
-          <a:bodyPr wrap="square" rtlCol="0" anchor="ctr"/>
-          <a:lstStyle/>
-          <a:p>
-            <a:pPr algn="ctr" indent="0" marL="0">
-              <a:buNone/>
-            </a:pPr>
-            <a:r>
-              <a:rPr lang="en-US" sz="1200" b="1" dirty="0">
-                <a:solidFill>
-                  <a:srgbClr val="4A90D9"/>
-                </a:solidFill>
-                <a:latin typeface="Arial" pitchFamily="34" charset="0"/>
-                <a:ea typeface="Arial" pitchFamily="34" charset="-122"/>
-                <a:cs typeface="Arial" pitchFamily="34" charset="-120"/>
-              </a:rPr>
-              <a:t>攻击模拟</a:t>
-            </a:r>
-            <a:endParaRPr lang="en-US" sz="1200" dirty="0"/>
-          </a:p>
-        </p:txBody>
-      </p:sp>
-      <p:sp>
-        <p:nvSpPr>
-          <p:cNvPr id="8" name="Text 6"/>
-          <p:cNvSpPr/>
-          <p:nvPr/>
-        </p:nvSpPr>
-        <p:spPr>
-          <a:xfrm>
-            <a:off x="2697480" y="1828800"/>
-            <a:ext cx="1783080" cy="2286000"/>
-          </a:xfrm>
-          <a:prstGeom prst="rect">
-            <a:avLst/>
-          </a:prstGeom>
-          <a:noFill/>
-          <a:ln/>
-        </p:spPr>
-        <p:txBody>
-          <a:bodyPr wrap="square" rtlCol="0" anchor="t"/>
-          <a:lstStyle/>
-          <a:p>
-            <a:pPr algn="l" indent="0" marL="0">
-              <a:buNone/>
-            </a:pPr>
-            <a:r>
-              <a:rPr lang="en-US" sz="1000" dirty="0">
-                <a:solidFill>
-                  <a:srgbClr val="888888"/>
-                </a:solidFill>
-                <a:latin typeface="Arial" pitchFamily="34" charset="0"/>
-                <a:ea typeface="Arial" pitchFamily="34" charset="-122"/>
-                <a:cs typeface="Arial" pitchFamily="34" charset="-120"/>
-              </a:rPr>
-              <a:t>• PoC Generator</a:t>
-            </a:r>
-            <a:endParaRPr lang="en-US" sz="1000" dirty="0"/>
-          </a:p>
-          <a:p>
-            <a:pPr algn="l" indent="0" marL="0">
-              <a:buNone/>
-            </a:pPr>
-            <a:r>
-              <a:rPr lang="en-US" sz="1000" dirty="0">
-                <a:solidFill>
-                  <a:srgbClr val="888888"/>
-                </a:solidFill>
-                <a:latin typeface="Arial" pitchFamily="34" charset="0"/>
-                <a:ea typeface="Arial" pitchFamily="34" charset="-122"/>
-                <a:cs typeface="Arial" pitchFamily="34" charset="-120"/>
-              </a:rPr>
-              <a:t>• Exploit Simulator</a:t>
-            </a:r>
-            <a:endParaRPr lang="en-US" sz="1000" dirty="0"/>
-          </a:p>
-          <a:p>
-            <a:pPr algn="l" indent="0" marL="0">
-              <a:buNone/>
-            </a:pPr>
-            <a:r>
-              <a:rPr lang="en-US" sz="1000" dirty="0">
-                <a:solidFill>
-                  <a:srgbClr val="888888"/>
-                </a:solidFill>
-                <a:latin typeface="Arial" pitchFamily="34" charset="0"/>
-                <a:ea typeface="Arial" pitchFamily="34" charset="-122"/>
-                <a:cs typeface="Arial" pitchFamily="34" charset="-120"/>
-              </a:rPr>
-              <a:t>• Fuzz Runner</a:t>
-            </a:r>
-            <a:endParaRPr lang="en-US" sz="1000" dirty="0"/>
-          </a:p>
-        </p:txBody>
-      </p:sp>
-      <p:sp>
-        <p:nvSpPr>
-          <p:cNvPr id="9" name="Shape 7"/>
-          <p:cNvSpPr/>
-          <p:nvPr/>
-        </p:nvSpPr>
-        <p:spPr>
-          <a:xfrm>
-            <a:off x="4754880" y="1188720"/>
-            <a:ext cx="1965960" cy="3200400"/>
-          </a:xfrm>
-          <a:prstGeom prst="rect">
-            <a:avLst/>
-          </a:prstGeom>
-          <a:solidFill>
-            <a:srgbClr val="1A1F3A"/>
-          </a:solidFill>
-          <a:ln w="12700">
-            <a:solidFill>
-              <a:srgbClr val="4A90D9"/>
-            </a:solidFill>
-            <a:prstDash val="solid"/>
-          </a:ln>
-        </p:spPr>
-      </p:sp>
-      <p:sp>
-        <p:nvSpPr>
-          <p:cNvPr id="10" name="Text 8"/>
-          <p:cNvSpPr/>
-          <p:nvPr/>
-        </p:nvSpPr>
-        <p:spPr>
-          <a:xfrm>
-            <a:off x="4846320" y="1280160"/>
-            <a:ext cx="1783080" cy="457200"/>
-          </a:xfrm>
-          <a:prstGeom prst="rect">
-            <a:avLst/>
-          </a:prstGeom>
-          <a:noFill/>
-          <a:ln/>
-        </p:spPr>
-        <p:txBody>
-          <a:bodyPr wrap="square" rtlCol="0" anchor="ctr"/>
-          <a:lstStyle/>
-          <a:p>
-            <a:pPr algn="ctr" indent="0" marL="0">
-              <a:buNone/>
-            </a:pPr>
-            <a:r>
-              <a:rPr lang="en-US" sz="1200" b="1" dirty="0">
-                <a:solidFill>
-                  <a:srgbClr val="4A90D9"/>
-                </a:solidFill>
-                <a:latin typeface="Arial" pitchFamily="34" charset="0"/>
-                <a:ea typeface="Arial" pitchFamily="34" charset="-122"/>
-                <a:cs typeface="Arial" pitchFamily="34" charset="-120"/>
-              </a:rPr>
-              <a:t>链上操作</a:t>
-            </a:r>
-            <a:endParaRPr lang="en-US" sz="1200" dirty="0"/>
-          </a:p>
-        </p:txBody>
-      </p:sp>
-      <p:sp>
-        <p:nvSpPr>
-          <p:cNvPr id="11" name="Text 9"/>
-          <p:cNvSpPr/>
-          <p:nvPr/>
-        </p:nvSpPr>
-        <p:spPr>
-          <a:xfrm>
-            <a:off x="4846320" y="1828800"/>
-            <a:ext cx="1783080" cy="2286000"/>
-          </a:xfrm>
-          <a:prstGeom prst="rect">
-            <a:avLst/>
-          </a:prstGeom>
-          <a:noFill/>
-          <a:ln/>
-        </p:spPr>
-        <p:txBody>
-          <a:bodyPr wrap="square" rtlCol="0" anchor="t"/>
-          <a:lstStyle/>
-          <a:p>
-            <a:pPr algn="l" indent="0" marL="0">
-              <a:buNone/>
-            </a:pPr>
-            <a:r>
-              <a:rPr lang="en-US" sz="1000" dirty="0">
-                <a:solidFill>
-                  <a:srgbClr val="888888"/>
-                </a:solidFill>
-                <a:latin typeface="Arial" pitchFamily="34" charset="0"/>
-                <a:ea typeface="Arial" pitchFamily="34" charset="-122"/>
-                <a:cs typeface="Arial" pitchFamily="34" charset="-120"/>
-              </a:rPr>
-              <a:t>• EAS Attest</a:t>
-            </a:r>
-            <a:endParaRPr lang="en-US" sz="1000" dirty="0"/>
-          </a:p>
-          <a:p>
-            <a:pPr algn="l" indent="0" marL="0">
-              <a:buNone/>
-            </a:pPr>
-            <a:r>
-              <a:rPr lang="en-US" sz="1000" dirty="0">
-                <a:solidFill>
-                  <a:srgbClr val="888888"/>
-                </a:solidFill>
-                <a:latin typeface="Arial" pitchFamily="34" charset="0"/>
-                <a:ea typeface="Arial" pitchFamily="34" charset="-122"/>
-                <a:cs typeface="Arial" pitchFamily="34" charset="-120"/>
-              </a:rPr>
-              <a:t>• Evidence Chain</a:t>
-            </a:r>
-            <a:endParaRPr lang="en-US" sz="1000" dirty="0"/>
-          </a:p>
-        </p:txBody>
-      </p:sp>
-      <p:sp>
-        <p:nvSpPr>
-          <p:cNvPr id="12" name="Shape 10"/>
-          <p:cNvSpPr/>
-          <p:nvPr/>
-        </p:nvSpPr>
-        <p:spPr>
-          <a:xfrm>
-            <a:off x="6903720" y="1188720"/>
-            <a:ext cx="1965960" cy="3200400"/>
-          </a:xfrm>
-          <a:prstGeom prst="rect">
-            <a:avLst/>
-          </a:prstGeom>
-          <a:solidFill>
-            <a:srgbClr val="1A1F3A"/>
-          </a:solidFill>
-          <a:ln w="12700">
-            <a:solidFill>
-              <a:srgbClr val="4A90D9"/>
-            </a:solidFill>
-            <a:prstDash val="solid"/>
-          </a:ln>
-        </p:spPr>
-      </p:sp>
-      <p:sp>
-        <p:nvSpPr>
-          <p:cNvPr id="13" name="Text 11"/>
-          <p:cNvSpPr/>
-          <p:nvPr/>
-        </p:nvSpPr>
-        <p:spPr>
-          <a:xfrm>
-            <a:off x="6995160" y="1280160"/>
-            <a:ext cx="1783080" cy="457200"/>
-          </a:xfrm>
-          <a:prstGeom prst="rect">
-            <a:avLst/>
-          </a:prstGeom>
-          <a:noFill/>
-          <a:ln/>
-        </p:spPr>
-        <p:txBody>
-          <a:bodyPr wrap="square" rtlCol="0" anchor="ctr"/>
-          <a:lstStyle/>
-          <a:p>
-            <a:pPr algn="ctr" indent="0" marL="0">
-              <a:buNone/>
-            </a:pPr>
-            <a:r>
-              <a:rPr lang="en-US" sz="1200" b="1" dirty="0">
-                <a:solidFill>
-                  <a:srgbClr val="4A90D9"/>
-                </a:solidFill>
-                <a:latin typeface="Arial" pitchFamily="34" charset="0"/>
-                <a:ea typeface="Arial" pitchFamily="34" charset="-122"/>
-                <a:cs typeface="Arial" pitchFamily="34" charset="-120"/>
-              </a:rPr>
-              <a:t>高级功能</a:t>
-            </a:r>
-            <a:endParaRPr lang="en-US" sz="1200" dirty="0"/>
-          </a:p>
-        </p:txBody>
-      </p:sp>
-      <p:sp>
-        <p:nvSpPr>
-          <p:cNvPr id="14" name="Text 12"/>
-          <p:cNvSpPr/>
-          <p:nvPr/>
-        </p:nvSpPr>
-        <p:spPr>
-          <a:xfrm>
-            <a:off x="6995160" y="1828800"/>
-            <a:ext cx="1783080" cy="2286000"/>
-          </a:xfrm>
-          <a:prstGeom prst="rect">
-            <a:avLst/>
-          </a:prstGeom>
-          <a:noFill/>
-          <a:ln/>
-        </p:spPr>
-        <p:txBody>
-          <a:bodyPr wrap="square" rtlCol="0" anchor="t"/>
-          <a:lstStyle/>
-          <a:p>
-            <a:pPr algn="l" indent="0" marL="0">
-              <a:buNone/>
-            </a:pPr>
-            <a:r>
-              <a:rPr lang="en-US" sz="1000" dirty="0">
-                <a:solidFill>
-                  <a:srgbClr val="888888"/>
-                </a:solidFill>
-                <a:latin typeface="Arial" pitchFamily="34" charset="0"/>
-                <a:ea typeface="Arial" pitchFamily="34" charset="-122"/>
-                <a:cs typeface="Arial" pitchFamily="34" charset="-120"/>
-              </a:rPr>
-              <a:t>• Protocol Scanner</a:t>
-            </a:r>
-            <a:endParaRPr lang="en-US" sz="1000" dirty="0"/>
-          </a:p>
-          <a:p>
-            <a:pPr algn="l" indent="0" marL="0">
-              <a:buNone/>
-            </a:pPr>
-            <a:r>
-              <a:rPr lang="en-US" sz="1000" dirty="0">
-                <a:solidFill>
-                  <a:srgbClr val="888888"/>
-                </a:solidFill>
-                <a:latin typeface="Arial" pitchFamily="34" charset="0"/>
-                <a:ea typeface="Arial" pitchFamily="34" charset="-122"/>
-                <a:cs typeface="Arial" pitchFamily="34" charset="-120"/>
-              </a:rPr>
-              <a:t>• Repair Validator</a:t>
-            </a:r>
-            <a:endParaRPr lang="en-US" sz="1000" dirty="0"/>
-          </a:p>
-          <a:p>
-            <a:pPr algn="l" indent="0" marL="0">
-              <a:buNone/>
-            </a:pPr>
-            <a:r>
-              <a:rPr lang="en-US" sz="1000" dirty="0">
-                <a:solidFill>
-                  <a:srgbClr val="888888"/>
-                </a:solidFill>
-                <a:latin typeface="Arial" pitchFamily="34" charset="0"/>
-                <a:ea typeface="Arial" pitchFamily="34" charset="-122"/>
-                <a:cs typeface="Arial" pitchFamily="34" charset="-120"/>
-              </a:rPr>
-              <a:t>• Incremental Auditor</a:t>
-            </a:r>
-            <a:endParaRPr lang="en-US" sz="1000" dirty="0"/>
-          </a:p>
-          <a:p>
-            <a:pPr algn="l" indent="0" marL="0">
-              <a:buNone/>
-            </a:pPr>
-            <a:r>
-              <a:rPr lang="en-US" sz="1000" dirty="0">
-                <a:solidFill>
-                  <a:srgbClr val="888888"/>
-                </a:solidFill>
-                <a:latin typeface="Arial" pitchFamily="34" charset="0"/>
-                <a:ea typeface="Arial" pitchFamily="34" charset="-122"/>
-                <a:cs typeface="Arial" pitchFamily="34" charset="-120"/>
-              </a:rPr>
-              <a:t>• GEV Analyzer</a:t>
-            </a:r>
-            <a:endParaRPr lang="en-US" sz="1000" dirty="0"/>
-          </a:p>
-          <a:p>
-            <a:pPr algn="l" indent="0" marL="0">
-              <a:buNone/>
-            </a:pPr>
-            <a:r>
-              <a:rPr lang="en-US" sz="1000" dirty="0">
-                <a:solidFill>
-                  <a:srgbClr val="888888"/>
-                </a:solidFill>
-                <a:latin typeface="Arial" pitchFamily="34" charset="0"/>
-                <a:ea typeface="Arial" pitchFamily="34" charset="-122"/>
-                <a:cs typeface="Arial" pitchFamily="34" charset="-120"/>
-              </a:rPr>
-              <a:t>• Knowledge Base</a:t>
-            </a:r>
-            <a:endParaRPr lang="en-US" sz="1000" dirty="0"/>
-          </a:p>
-        </p:txBody>
-      </p:sp>
-      <p:sp>
-        <p:nvSpPr>
-          <p:cNvPr id="15" name="Text 13"/>
+      <p:pic>
+        <p:nvPicPr>
+          <p:cNvPr id="3" name="Image 0" descr="/root/projects/glm-code/ppt-assets/mcp-tools.png">    </p:cNvPr>
+          <p:cNvPicPr>
+            <a:picLocks noChangeAspect="1"/>
+          </p:cNvPicPr>
+          <p:nvPr/>
+        </p:nvPicPr>
+        <p:blipFill>
+          <a:blip r:embed="rId1"/>
+          <a:stretch>
+            <a:fillRect/>
+          </a:stretch>
+        </p:blipFill>
+        <p:spPr>
+          <a:xfrm>
+            <a:off x="457200" y="1097280"/>
+            <a:ext cx="8229600" cy="3474720"/>
+          </a:xfrm>
+          <a:prstGeom prst="rect">
+            <a:avLst/>
+          </a:prstGeom>
+        </p:spPr>
+      </p:pic>
+      <p:sp>
+        <p:nvSpPr>
+          <p:cNvPr id="4" name="Text 1"/>
           <p:cNvSpPr/>
           <p:nvPr/>
         </p:nvSpPr>

</xml_diff>

<commit_message>
style: unify PPT with landing page monochrome style
Colors: pure black bg (#000), white text, gray (#666) secondary
Font: Courier New (monospace) throughout
Removed: blue accents, bright red/green/orange
SVGs: updated border colors to match (#333333)

All 5 SVGs re-rendered with new palette.
</commit_message>
<xml_diff>
--- a/ppt-assets/Athena-Hackathon.pptx
+++ b/ppt-assets/Athena-Hackathon.pptx
@@ -1658,7 +1658,7 @@
     <p:bg>
       <p:bgPr>
         <a:solidFill>
-          <a:srgbClr val="0A0A0A"/>
+          <a:srgbClr val="000000"/>
         </a:solidFill>
       </p:bgPr>
     </p:bg>
@@ -1729,9 +1729,9 @@
                 <a:solidFill>
                   <a:srgbClr val="FFFFFF"/>
                 </a:solidFill>
-                <a:latin typeface="Arial" pitchFamily="34" charset="0"/>
-                <a:ea typeface="Arial" pitchFamily="34" charset="-122"/>
-                <a:cs typeface="Arial" pitchFamily="34" charset="-120"/>
+                <a:latin typeface="Courier New" pitchFamily="34" charset="0"/>
+                <a:ea typeface="Courier New" pitchFamily="34" charset="-122"/>
+                <a:cs typeface="Courier New" pitchFamily="34" charset="-120"/>
               </a:rPr>
               <a:t>ATHENA</a:t>
             </a:r>
@@ -1766,11 +1766,11 @@
             <a:r>
               <a:rPr lang="en-US" sz="2800" dirty="0">
                 <a:solidFill>
-                  <a:srgbClr val="4A90D9"/>
-                </a:solidFill>
-                <a:latin typeface="Arial" pitchFamily="34" charset="0"/>
-                <a:ea typeface="Arial" pitchFamily="34" charset="-122"/>
-                <a:cs typeface="Arial" pitchFamily="34" charset="-120"/>
+                  <a:srgbClr val="333333"/>
+                </a:solidFill>
+                <a:latin typeface="Courier New" pitchFamily="34" charset="0"/>
+                <a:ea typeface="Courier New" pitchFamily="34" charset="-122"/>
+                <a:cs typeface="Courier New" pitchFamily="34" charset="-120"/>
               </a:rPr>
               <a:t>Web3 Security Audit Agent</a:t>
             </a:r>
@@ -1805,11 +1805,11 @@
             <a:r>
               <a:rPr lang="en-US" sz="1600" dirty="0">
                 <a:solidFill>
-                  <a:srgbClr val="888888"/>
-                </a:solidFill>
-                <a:latin typeface="Arial" pitchFamily="34" charset="0"/>
-                <a:ea typeface="Arial" pitchFamily="34" charset="-122"/>
-                <a:cs typeface="Arial" pitchFamily="34" charset="-120"/>
+                  <a:srgbClr val="666666"/>
+                </a:solidFill>
+                <a:latin typeface="Courier New" pitchFamily="34" charset="0"/>
+                <a:ea typeface="Courier New" pitchFamily="34" charset="-122"/>
+                <a:cs typeface="Courier New" pitchFamily="34" charset="-120"/>
               </a:rPr>
               <a:t>基于 GLM-5.1 长程任务能力的 Web3 安全审计闭环</a:t>
             </a:r>
@@ -1844,11 +1844,11 @@
             <a:r>
               <a:rPr lang="en-US" sz="1400" dirty="0">
                 <a:solidFill>
-                  <a:srgbClr val="888888"/>
-                </a:solidFill>
-                <a:latin typeface="Arial" pitchFamily="34" charset="0"/>
-                <a:ea typeface="Arial" pitchFamily="34" charset="-122"/>
-                <a:cs typeface="Arial" pitchFamily="34" charset="-120"/>
+                  <a:srgbClr val="666666"/>
+                </a:solidFill>
+                <a:latin typeface="Courier New" pitchFamily="34" charset="0"/>
+                <a:ea typeface="Courier New" pitchFamily="34" charset="-122"/>
+                <a:cs typeface="Courier New" pitchFamily="34" charset="-120"/>
               </a:rPr>
               <a:t>Z.AI 赛道 · Tiya Degurechaff</a:t>
             </a:r>
@@ -1883,7 +1883,7 @@
             <a:r>
               <a:rPr lang="en-US" sz="1000" dirty="0">
                 <a:solidFill>
-                  <a:srgbClr val="888888"/>
+                  <a:srgbClr val="666666"/>
                 </a:solidFill>
               </a:rPr>
               <a:t>Athena · Z.AI Hackathon · GLM-5.1</a:t>
@@ -1906,7 +1906,7 @@
     <p:bg>
       <p:bgPr>
         <a:solidFill>
-          <a:srgbClr val="0A0A0A"/>
+          <a:srgbClr val="000000"/>
         </a:solidFill>
       </p:bgPr>
     </p:bg>
@@ -1953,9 +1953,9 @@
                 <a:solidFill>
                   <a:srgbClr val="FFFFFF"/>
                 </a:solidFill>
-                <a:latin typeface="Arial" pitchFamily="34" charset="0"/>
-                <a:ea typeface="Arial" pitchFamily="34" charset="-122"/>
-                <a:cs typeface="Arial" pitchFamily="34" charset="-120"/>
+                <a:latin typeface="Courier New" pitchFamily="34" charset="0"/>
+                <a:ea typeface="Courier New" pitchFamily="34" charset="-122"/>
+                <a:cs typeface="Courier New" pitchFamily="34" charset="-120"/>
               </a:rPr>
               <a:t>Athena 的价值</a:t>
             </a:r>
@@ -1978,11 +1978,11 @@
             <a:avLst/>
           </a:prstGeom>
           <a:solidFill>
-            <a:srgbClr val="1A1F3A"/>
+            <a:srgbClr val="0A0A0A"/>
           </a:solidFill>
           <a:ln w="12700">
             <a:solidFill>
-              <a:srgbClr val="4A90D9"/>
+              <a:srgbClr val="333333"/>
             </a:solidFill>
             <a:prstDash val="solid"/>
           </a:ln>
@@ -2015,11 +2015,11 @@
             <a:r>
               <a:rPr lang="en-US" sz="1400" b="1" dirty="0">
                 <a:solidFill>
-                  <a:srgbClr val="888888"/>
-                </a:solidFill>
-                <a:latin typeface="Arial" pitchFamily="34" charset="0"/>
-                <a:ea typeface="Arial" pitchFamily="34" charset="-122"/>
-                <a:cs typeface="Arial" pitchFamily="34" charset="-120"/>
+                  <a:srgbClr val="666666"/>
+                </a:solidFill>
+                <a:latin typeface="Courier New" pitchFamily="34" charset="0"/>
+                <a:ea typeface="Courier New" pitchFamily="34" charset="-122"/>
+                <a:cs typeface="Courier New" pitchFamily="34" charset="-120"/>
               </a:rPr>
               <a:t>核心价值</a:t>
             </a:r>
@@ -2038,11 +2038,11 @@
             <a:r>
               <a:rPr lang="en-US" sz="1400" dirty="0">
                 <a:solidFill>
-                  <a:srgbClr val="888888"/>
-                </a:solidFill>
-                <a:latin typeface="Arial" pitchFamily="34" charset="0"/>
-                <a:ea typeface="Arial" pitchFamily="34" charset="-122"/>
-                <a:cs typeface="Arial" pitchFamily="34" charset="-120"/>
+                  <a:srgbClr val="666666"/>
+                </a:solidFill>
+                <a:latin typeface="Courier New" pitchFamily="34" charset="0"/>
+                <a:ea typeface="Courier New" pitchFamily="34" charset="-122"/>
+                <a:cs typeface="Courier New" pitchFamily="34" charset="-120"/>
               </a:rPr>
               <a:t>• GLM-5.1 长程任务能力 → Agent 可以自主完成复杂任务</a:t>
             </a:r>
@@ -2055,11 +2055,11 @@
             <a:r>
               <a:rPr lang="en-US" sz="1400" dirty="0">
                 <a:solidFill>
-                  <a:srgbClr val="888888"/>
-                </a:solidFill>
-                <a:latin typeface="Arial" pitchFamily="34" charset="0"/>
-                <a:ea typeface="Arial" pitchFamily="34" charset="-122"/>
-                <a:cs typeface="Arial" pitchFamily="34" charset="-120"/>
+                  <a:srgbClr val="666666"/>
+                </a:solidFill>
+                <a:latin typeface="Courier New" pitchFamily="34" charset="0"/>
+                <a:ea typeface="Courier New" pitchFamily="34" charset="-122"/>
+                <a:cs typeface="Courier New" pitchFamily="34" charset="-120"/>
               </a:rPr>
               <a:t>• Web3 审计闭环 → Agent 经济的完整展示</a:t>
             </a:r>
@@ -2072,11 +2072,11 @@
             <a:r>
               <a:rPr lang="en-US" sz="1400" dirty="0">
                 <a:solidFill>
-                  <a:srgbClr val="888888"/>
-                </a:solidFill>
-                <a:latin typeface="Arial" pitchFamily="34" charset="0"/>
-                <a:ea typeface="Arial" pitchFamily="34" charset="-122"/>
-                <a:cs typeface="Arial" pitchFamily="34" charset="-120"/>
+                  <a:srgbClr val="666666"/>
+                </a:solidFill>
+                <a:latin typeface="Courier New" pitchFamily="34" charset="0"/>
+                <a:ea typeface="Courier New" pitchFamily="34" charset="-122"/>
+                <a:cs typeface="Courier New" pitchFamily="34" charset="-120"/>
               </a:rPr>
               <a:t>• 链上认证 → Agent 产出可验证、可交易</a:t>
             </a:r>
@@ -2099,7 +2099,7 @@
             <a:avLst/>
           </a:prstGeom>
           <a:solidFill>
-            <a:srgbClr val="1A1F3A"/>
+            <a:srgbClr val="0A0A0A"/>
           </a:solidFill>
           <a:ln w="12700">
             <a:solidFill>
@@ -2136,11 +2136,11 @@
             <a:r>
               <a:rPr lang="en-US" sz="1400" b="1" dirty="0">
                 <a:solidFill>
-                  <a:srgbClr val="888888"/>
-                </a:solidFill>
-                <a:latin typeface="Arial" pitchFamily="34" charset="0"/>
-                <a:ea typeface="Arial" pitchFamily="34" charset="-122"/>
-                <a:cs typeface="Arial" pitchFamily="34" charset="-120"/>
+                  <a:srgbClr val="666666"/>
+                </a:solidFill>
+                <a:latin typeface="Courier New" pitchFamily="34" charset="0"/>
+                <a:ea typeface="Courier New" pitchFamily="34" charset="-122"/>
+                <a:cs typeface="Courier New" pitchFamily="34" charset="-120"/>
               </a:rPr>
               <a:t>Roadmap</a:t>
             </a:r>
@@ -2159,11 +2159,11 @@
             <a:r>
               <a:rPr lang="en-US" sz="1400" dirty="0">
                 <a:solidFill>
-                  <a:srgbClr val="888888"/>
-                </a:solidFill>
-                <a:latin typeface="Arial" pitchFamily="34" charset="0"/>
-                <a:ea typeface="Arial" pitchFamily="34" charset="-122"/>
-                <a:cs typeface="Arial" pitchFamily="34" charset="-120"/>
+                  <a:srgbClr val="666666"/>
+                </a:solidFill>
+                <a:latin typeface="Courier New" pitchFamily="34" charset="0"/>
+                <a:ea typeface="Courier New" pitchFamily="34" charset="-122"/>
+                <a:cs typeface="Courier New" pitchFamily="34" charset="-120"/>
               </a:rPr>
               <a:t>• ZK 隐私审计（v2）</a:t>
             </a:r>
@@ -2176,11 +2176,11 @@
             <a:r>
               <a:rPr lang="en-US" sz="1400" dirty="0">
                 <a:solidFill>
-                  <a:srgbClr val="888888"/>
-                </a:solidFill>
-                <a:latin typeface="Arial" pitchFamily="34" charset="0"/>
-                <a:ea typeface="Arial" pitchFamily="34" charset="-122"/>
-                <a:cs typeface="Arial" pitchFamily="34" charset="-120"/>
+                  <a:srgbClr val="666666"/>
+                </a:solidFill>
+                <a:latin typeface="Courier New" pitchFamily="34" charset="0"/>
+                <a:ea typeface="Courier New" pitchFamily="34" charset="-122"/>
+                <a:cs typeface="Courier New" pitchFamily="34" charset="-120"/>
               </a:rPr>
               <a:t>• 多链部署（Ethereum、Base、Arbitrum）</a:t>
             </a:r>
@@ -2193,11 +2193,11 @@
             <a:r>
               <a:rPr lang="en-US" sz="1400" dirty="0">
                 <a:solidFill>
-                  <a:srgbClr val="888888"/>
-                </a:solidFill>
-                <a:latin typeface="Arial" pitchFamily="34" charset="0"/>
-                <a:ea typeface="Arial" pitchFamily="34" charset="-122"/>
-                <a:cs typeface="Arial" pitchFamily="34" charset="-120"/>
+                  <a:srgbClr val="666666"/>
+                </a:solidFill>
+                <a:latin typeface="Courier New" pitchFamily="34" charset="0"/>
+                <a:ea typeface="Courier New" pitchFamily="34" charset="-122"/>
+                <a:cs typeface="Courier New" pitchFamily="34" charset="-120"/>
               </a:rPr>
               <a:t>• Agent 审计市场（Agent ↔ Agent 交易）</a:t>
             </a:r>
@@ -2210,11 +2210,11 @@
             <a:r>
               <a:rPr lang="en-US" sz="1400" dirty="0">
                 <a:solidFill>
-                  <a:srgbClr val="888888"/>
-                </a:solidFill>
-                <a:latin typeface="Arial" pitchFamily="34" charset="0"/>
-                <a:ea typeface="Arial" pitchFamily="34" charset="-122"/>
-                <a:cs typeface="Arial" pitchFamily="34" charset="-120"/>
+                  <a:srgbClr val="666666"/>
+                </a:solidFill>
+                <a:latin typeface="Courier New" pitchFamily="34" charset="0"/>
+                <a:ea typeface="Courier New" pitchFamily="34" charset="-122"/>
+                <a:cs typeface="Courier New" pitchFamily="34" charset="-120"/>
               </a:rPr>
               <a:t>• 真实协议审计（Curve、Aave）</a:t>
             </a:r>
@@ -2251,9 +2251,9 @@
                 <a:solidFill>
                   <a:srgbClr val="D4A535"/>
                 </a:solidFill>
-                <a:latin typeface="Arial" pitchFamily="34" charset="0"/>
-                <a:ea typeface="Arial" pitchFamily="34" charset="-122"/>
-                <a:cs typeface="Arial" pitchFamily="34" charset="-120"/>
+                <a:latin typeface="Courier New" pitchFamily="34" charset="0"/>
+                <a:ea typeface="Courier New" pitchFamily="34" charset="-122"/>
+                <a:cs typeface="Courier New" pitchFamily="34" charset="-120"/>
               </a:rPr>
               <a:t>感谢 Z.AI 赛道支持！</a:t>
             </a:r>
@@ -2288,7 +2288,7 @@
             <a:r>
               <a:rPr lang="en-US" sz="1000" dirty="0">
                 <a:solidFill>
-                  <a:srgbClr val="888888"/>
+                  <a:srgbClr val="666666"/>
                 </a:solidFill>
               </a:rPr>
               <a:t>Athena · Z.AI Hackathon · GLM-5.1</a:t>
@@ -2311,7 +2311,7 @@
     <p:bg>
       <p:bgPr>
         <a:solidFill>
-          <a:srgbClr val="0A0A0A"/>
+          <a:srgbClr val="000000"/>
         </a:solidFill>
       </p:bgPr>
     </p:bg>
@@ -2358,9 +2358,9 @@
                 <a:solidFill>
                   <a:srgbClr val="FFFFFF"/>
                 </a:solidFill>
-                <a:latin typeface="Arial" pitchFamily="34" charset="0"/>
-                <a:ea typeface="Arial" pitchFamily="34" charset="-122"/>
-                <a:cs typeface="Arial" pitchFamily="34" charset="-120"/>
+                <a:latin typeface="Courier New" pitchFamily="34" charset="0"/>
+                <a:ea typeface="Courier New" pitchFamily="34" charset="-122"/>
+                <a:cs typeface="Courier New" pitchFamily="34" charset="-120"/>
               </a:rPr>
               <a:t>Web3 安全审计的现状</a:t>
             </a:r>
@@ -2395,11 +2395,11 @@
             <a:r>
               <a:rPr lang="en-US" sz="1600" b="1" dirty="0">
                 <a:solidFill>
-                  <a:srgbClr val="888888"/>
-                </a:solidFill>
-                <a:latin typeface="Arial" pitchFamily="34" charset="0"/>
-                <a:ea typeface="Arial" pitchFamily="34" charset="-122"/>
-                <a:cs typeface="Arial" pitchFamily="34" charset="-120"/>
+                  <a:srgbClr val="666666"/>
+                </a:solidFill>
+                <a:latin typeface="Courier New" pitchFamily="34" charset="0"/>
+                <a:ea typeface="Courier New" pitchFamily="34" charset="-122"/>
+                <a:cs typeface="Courier New" pitchFamily="34" charset="-120"/>
               </a:rPr>
               <a:t>人工审计</a:t>
             </a:r>
@@ -2412,11 +2412,11 @@
             <a:r>
               <a:rPr lang="en-US" sz="1600" dirty="0">
                 <a:solidFill>
-                  <a:srgbClr val="888888"/>
-                </a:solidFill>
-                <a:latin typeface="Arial" pitchFamily="34" charset="0"/>
-                <a:ea typeface="Arial" pitchFamily="34" charset="-122"/>
-                <a:cs typeface="Arial" pitchFamily="34" charset="-120"/>
+                  <a:srgbClr val="666666"/>
+                </a:solidFill>
+                <a:latin typeface="Courier New" pitchFamily="34" charset="0"/>
+                <a:ea typeface="Courier New" pitchFamily="34" charset="-122"/>
+                <a:cs typeface="Courier New" pitchFamily="34" charset="-120"/>
               </a:rPr>
               <a:t>慢（2-4周）、贵（$5万+）、易遗漏</a:t>
             </a:r>
@@ -2435,11 +2435,11 @@
             <a:r>
               <a:rPr lang="en-US" sz="1600" b="1" dirty="0">
                 <a:solidFill>
-                  <a:srgbClr val="888888"/>
-                </a:solidFill>
-                <a:latin typeface="Arial" pitchFamily="34" charset="0"/>
-                <a:ea typeface="Arial" pitchFamily="34" charset="-122"/>
-                <a:cs typeface="Arial" pitchFamily="34" charset="-120"/>
+                  <a:srgbClr val="666666"/>
+                </a:solidFill>
+                <a:latin typeface="Courier New" pitchFamily="34" charset="0"/>
+                <a:ea typeface="Courier New" pitchFamily="34" charset="-122"/>
+                <a:cs typeface="Courier New" pitchFamily="34" charset="-120"/>
               </a:rPr>
               <a:t>AI 审计</a:t>
             </a:r>
@@ -2452,11 +2452,11 @@
             <a:r>
               <a:rPr lang="en-US" sz="1600" dirty="0">
                 <a:solidFill>
-                  <a:srgbClr val="888888"/>
-                </a:solidFill>
-                <a:latin typeface="Arial" pitchFamily="34" charset="0"/>
-                <a:ea typeface="Arial" pitchFamily="34" charset="-122"/>
-                <a:cs typeface="Arial" pitchFamily="34" charset="-120"/>
+                  <a:srgbClr val="666666"/>
+                </a:solidFill>
+                <a:latin typeface="Courier New" pitchFamily="34" charset="0"/>
+                <a:ea typeface="Courier New" pitchFamily="34" charset="-122"/>
+                <a:cs typeface="Courier New" pitchFamily="34" charset="-120"/>
               </a:rPr>
               <a:t>单步推理、无链上验证、无证据链</a:t>
             </a:r>
@@ -2475,11 +2475,11 @@
             <a:r>
               <a:rPr lang="en-US" sz="1600" b="1" dirty="0">
                 <a:solidFill>
-                  <a:srgbClr val="888888"/>
-                </a:solidFill>
-                <a:latin typeface="Arial" pitchFamily="34" charset="0"/>
-                <a:ea typeface="Arial" pitchFamily="34" charset="-122"/>
-                <a:cs typeface="Arial" pitchFamily="34" charset="-120"/>
+                  <a:srgbClr val="666666"/>
+                </a:solidFill>
+                <a:latin typeface="Courier New" pitchFamily="34" charset="0"/>
+                <a:ea typeface="Courier New" pitchFamily="34" charset="-122"/>
+                <a:cs typeface="Courier New" pitchFamily="34" charset="-120"/>
               </a:rPr>
               <a:t>Agent 经济雏形</a:t>
             </a:r>
@@ -2492,11 +2492,11 @@
             <a:r>
               <a:rPr lang="en-US" sz="1600" dirty="0">
                 <a:solidFill>
-                  <a:srgbClr val="888888"/>
-                </a:solidFill>
-                <a:latin typeface="Arial" pitchFamily="34" charset="0"/>
-                <a:ea typeface="Arial" pitchFamily="34" charset="-122"/>
-                <a:cs typeface="Arial" pitchFamily="34" charset="-120"/>
+                  <a:srgbClr val="666666"/>
+                </a:solidFill>
+                <a:latin typeface="Courier New" pitchFamily="34" charset="0"/>
+                <a:ea typeface="Courier New" pitchFamily="34" charset="-122"/>
+                <a:cs typeface="Courier New" pitchFamily="34" charset="-120"/>
               </a:rPr>
               <a:t>AI Agent 可以自主完成审计，但缺乏闭环</a:t>
             </a:r>
@@ -2519,11 +2519,11 @@
             <a:avLst/>
           </a:prstGeom>
           <a:solidFill>
-            <a:srgbClr val="1A1F3A"/>
+            <a:srgbClr val="0A0A0A"/>
           </a:solidFill>
           <a:ln w="12700">
             <a:solidFill>
-              <a:srgbClr val="4A90D9"/>
+              <a:srgbClr val="333333"/>
             </a:solidFill>
             <a:prstDash val="solid"/>
           </a:ln>
@@ -2556,11 +2556,11 @@
             <a:r>
               <a:rPr lang="en-US" sz="1400" b="1" dirty="0">
                 <a:solidFill>
-                  <a:srgbClr val="4A90D9"/>
-                </a:solidFill>
-                <a:latin typeface="Arial" pitchFamily="34" charset="0"/>
-                <a:ea typeface="Arial" pitchFamily="34" charset="-122"/>
-                <a:cs typeface="Arial" pitchFamily="34" charset="-120"/>
+                  <a:srgbClr val="333333"/>
+                </a:solidFill>
+                <a:latin typeface="Courier New" pitchFamily="34" charset="0"/>
+                <a:ea typeface="Courier New" pitchFamily="34" charset="-122"/>
+                <a:cs typeface="Courier New" pitchFamily="34" charset="-120"/>
               </a:rPr>
               <a:t>核心问题：如何让 AI Agent 完成从漏洞发现到链上认证的完整闭环？</a:t>
             </a:r>
@@ -2595,7 +2595,7 @@
             <a:r>
               <a:rPr lang="en-US" sz="1000" dirty="0">
                 <a:solidFill>
-                  <a:srgbClr val="888888"/>
+                  <a:srgbClr val="666666"/>
                 </a:solidFill>
               </a:rPr>
               <a:t>Athena · Z.AI Hackathon · GLM-5.1</a:t>
@@ -2618,7 +2618,7 @@
     <p:bg>
       <p:bgPr>
         <a:solidFill>
-          <a:srgbClr val="0A0A0A"/>
+          <a:srgbClr val="000000"/>
         </a:solidFill>
       </p:bgPr>
     </p:bg>
@@ -2665,9 +2665,9 @@
                 <a:solidFill>
                   <a:srgbClr val="FFFFFF"/>
                 </a:solidFill>
-                <a:latin typeface="Arial" pitchFamily="34" charset="0"/>
-                <a:ea typeface="Arial" pitchFamily="34" charset="-122"/>
-                <a:cs typeface="Arial" pitchFamily="34" charset="-120"/>
+                <a:latin typeface="Courier New" pitchFamily="34" charset="0"/>
+                <a:ea typeface="Courier New" pitchFamily="34" charset="-122"/>
+                <a:cs typeface="Courier New" pitchFamily="34" charset="-120"/>
               </a:rPr>
               <a:t>为什么是 GLM-5.1？</a:t>
             </a:r>
@@ -2690,11 +2690,11 @@
             <a:avLst/>
           </a:prstGeom>
           <a:solidFill>
-            <a:srgbClr val="1A1F3A"/>
+            <a:srgbClr val="0A0A0A"/>
           </a:solidFill>
           <a:ln w="12700">
             <a:solidFill>
-              <a:srgbClr val="888888"/>
+              <a:srgbClr val="666666"/>
             </a:solidFill>
             <a:prstDash val="solid"/>
           </a:ln>
@@ -2727,11 +2727,11 @@
             <a:r>
               <a:rPr lang="en-US" sz="1600" b="1" dirty="0">
                 <a:solidFill>
-                  <a:srgbClr val="888888"/>
-                </a:solidFill>
-                <a:latin typeface="Arial" pitchFamily="34" charset="0"/>
-                <a:ea typeface="Arial" pitchFamily="34" charset="-122"/>
-                <a:cs typeface="Arial" pitchFamily="34" charset="-120"/>
+                  <a:srgbClr val="666666"/>
+                </a:solidFill>
+                <a:latin typeface="Courier New" pitchFamily="34" charset="0"/>
+                <a:ea typeface="Courier New" pitchFamily="34" charset="-122"/>
+                <a:cs typeface="Courier New" pitchFamily="34" charset="-120"/>
               </a:rPr>
               <a:t>普通 LLM（单步推理）</a:t>
             </a:r>
@@ -2766,11 +2766,11 @@
             <a:r>
               <a:rPr lang="en-US" sz="1400" dirty="0">
                 <a:solidFill>
-                  <a:srgbClr val="FF0000"/>
-                </a:solidFill>
-                <a:latin typeface="Arial" pitchFamily="34" charset="0"/>
-                <a:ea typeface="Arial" pitchFamily="34" charset="-122"/>
-                <a:cs typeface="Arial" pitchFamily="34" charset="-120"/>
+                  <a:srgbClr val="888888"/>
+                </a:solidFill>
+                <a:latin typeface="Courier New" pitchFamily="34" charset="0"/>
+                <a:ea typeface="Courier New" pitchFamily="34" charset="-122"/>
+                <a:cs typeface="Courier New" pitchFamily="34" charset="-120"/>
               </a:rPr>
               <a:t>× 需要多次人工介入</a:t>
             </a:r>
@@ -2783,11 +2783,11 @@
             <a:r>
               <a:rPr lang="en-US" sz="1400" dirty="0">
                 <a:solidFill>
-                  <a:srgbClr val="FF0000"/>
-                </a:solidFill>
-                <a:latin typeface="Arial" pitchFamily="34" charset="0"/>
-                <a:ea typeface="Arial" pitchFamily="34" charset="-122"/>
-                <a:cs typeface="Arial" pitchFamily="34" charset="-120"/>
+                  <a:srgbClr val="888888"/>
+                </a:solidFill>
+                <a:latin typeface="Courier New" pitchFamily="34" charset="0"/>
+                <a:ea typeface="Courier New" pitchFamily="34" charset="-122"/>
+                <a:cs typeface="Courier New" pitchFamily="34" charset="-120"/>
               </a:rPr>
               <a:t>× 无法跨步骤传递上下文</a:t>
             </a:r>
@@ -2800,11 +2800,11 @@
             <a:r>
               <a:rPr lang="en-US" sz="1400" dirty="0">
                 <a:solidFill>
-                  <a:srgbClr val="FF0000"/>
-                </a:solidFill>
-                <a:latin typeface="Arial" pitchFamily="34" charset="0"/>
-                <a:ea typeface="Arial" pitchFamily="34" charset="-122"/>
-                <a:cs typeface="Arial" pitchFamily="34" charset="-120"/>
+                  <a:srgbClr val="888888"/>
+                </a:solidFill>
+                <a:latin typeface="Courier New" pitchFamily="34" charset="0"/>
+                <a:ea typeface="Courier New" pitchFamily="34" charset="-122"/>
+                <a:cs typeface="Courier New" pitchFamily="34" charset="-120"/>
               </a:rPr>
               <a:t>× 无法协调多个工具</a:t>
             </a:r>
@@ -2827,11 +2827,11 @@
             <a:avLst/>
           </a:prstGeom>
           <a:solidFill>
-            <a:srgbClr val="1A1F3A"/>
+            <a:srgbClr val="0A0A0A"/>
           </a:solidFill>
           <a:ln w="25400">
             <a:solidFill>
-              <a:srgbClr val="4A90D9"/>
+              <a:srgbClr val="333333"/>
             </a:solidFill>
             <a:prstDash val="solid"/>
           </a:ln>
@@ -2864,11 +2864,11 @@
             <a:r>
               <a:rPr lang="en-US" sz="1600" b="1" dirty="0">
                 <a:solidFill>
-                  <a:srgbClr val="4A90D9"/>
-                </a:solidFill>
-                <a:latin typeface="Arial" pitchFamily="34" charset="0"/>
-                <a:ea typeface="Arial" pitchFamily="34" charset="-122"/>
-                <a:cs typeface="Arial" pitchFamily="34" charset="-120"/>
+                  <a:srgbClr val="333333"/>
+                </a:solidFill>
+                <a:latin typeface="Courier New" pitchFamily="34" charset="0"/>
+                <a:ea typeface="Courier New" pitchFamily="34" charset="-122"/>
+                <a:cs typeface="Courier New" pitchFamily="34" charset="-120"/>
               </a:rPr>
               <a:t>GLM-5.1（长程推理）</a:t>
             </a:r>
@@ -2903,11 +2903,11 @@
             <a:r>
               <a:rPr lang="en-US" sz="1400" dirty="0">
                 <a:solidFill>
-                  <a:srgbClr val="00FF00"/>
-                </a:solidFill>
-                <a:latin typeface="Arial" pitchFamily="34" charset="0"/>
-                <a:ea typeface="Arial" pitchFamily="34" charset="-122"/>
-                <a:cs typeface="Arial" pitchFamily="34" charset="-120"/>
+                  <a:srgbClr val="888888"/>
+                </a:solidFill>
+                <a:latin typeface="Courier New" pitchFamily="34" charset="0"/>
+                <a:ea typeface="Courier New" pitchFamily="34" charset="-122"/>
+                <a:cs typeface="Courier New" pitchFamily="34" charset="-120"/>
               </a:rPr>
               <a:t>✓ 单次会话完成 8 步审计闭环</a:t>
             </a:r>
@@ -2920,11 +2920,11 @@
             <a:r>
               <a:rPr lang="en-US" sz="1400" dirty="0">
                 <a:solidFill>
-                  <a:srgbClr val="00FF00"/>
-                </a:solidFill>
-                <a:latin typeface="Arial" pitchFamily="34" charset="0"/>
-                <a:ea typeface="Arial" pitchFamily="34" charset="-122"/>
-                <a:cs typeface="Arial" pitchFamily="34" charset="-120"/>
+                  <a:srgbClr val="888888"/>
+                </a:solidFill>
+                <a:latin typeface="Courier New" pitchFamily="34" charset="0"/>
+                <a:ea typeface="Courier New" pitchFamily="34" charset="-122"/>
+                <a:cs typeface="Courier New" pitchFamily="34" charset="-120"/>
               </a:rPr>
               <a:t>✓ 200K 上下文，跨步骤记忆</a:t>
             </a:r>
@@ -2937,11 +2937,11 @@
             <a:r>
               <a:rPr lang="en-US" sz="1400" dirty="0">
                 <a:solidFill>
-                  <a:srgbClr val="00FF00"/>
-                </a:solidFill>
-                <a:latin typeface="Arial" pitchFamily="34" charset="0"/>
-                <a:ea typeface="Arial" pitchFamily="34" charset="-122"/>
-                <a:cs typeface="Arial" pitchFamily="34" charset="-120"/>
+                  <a:srgbClr val="888888"/>
+                </a:solidFill>
+                <a:latin typeface="Courier New" pitchFamily="34" charset="0"/>
+                <a:ea typeface="Courier New" pitchFamily="34" charset="-122"/>
+                <a:cs typeface="Courier New" pitchFamily="34" charset="-120"/>
               </a:rPr>
               <a:t>✓ 协调 13 个 MCP 工具</a:t>
             </a:r>
@@ -2954,11 +2954,11 @@
             <a:r>
               <a:rPr lang="en-US" sz="1400" dirty="0">
                 <a:solidFill>
-                  <a:srgbClr val="00FF00"/>
-                </a:solidFill>
-                <a:latin typeface="Arial" pitchFamily="34" charset="0"/>
-                <a:ea typeface="Arial" pitchFamily="34" charset="-122"/>
-                <a:cs typeface="Arial" pitchFamily="34" charset="-120"/>
+                  <a:srgbClr val="888888"/>
+                </a:solidFill>
+                <a:latin typeface="Courier New" pitchFamily="34" charset="0"/>
+                <a:ea typeface="Courier New" pitchFamily="34" charset="-122"/>
+                <a:cs typeface="Courier New" pitchFamily="34" charset="-120"/>
               </a:rPr>
               <a:t>✓ 驱动 12 个并行 Agent</a:t>
             </a:r>
@@ -2993,7 +2993,7 @@
             <a:r>
               <a:rPr lang="en-US" sz="1000" dirty="0">
                 <a:solidFill>
-                  <a:srgbClr val="888888"/>
+                  <a:srgbClr val="666666"/>
                 </a:solidFill>
               </a:rPr>
               <a:t>Athena · Z.AI Hackathon · GLM-5.1</a:t>
@@ -3016,7 +3016,7 @@
     <p:bg>
       <p:bgPr>
         <a:solidFill>
-          <a:srgbClr val="0A0A0A"/>
+          <a:srgbClr val="000000"/>
         </a:solidFill>
       </p:bgPr>
     </p:bg>
@@ -3063,9 +3063,9 @@
                 <a:solidFill>
                   <a:srgbClr val="FFFFFF"/>
                 </a:solidFill>
-                <a:latin typeface="Arial" pitchFamily="34" charset="0"/>
-                <a:ea typeface="Arial" pitchFamily="34" charset="-122"/>
-                <a:cs typeface="Arial" pitchFamily="34" charset="-120"/>
+                <a:latin typeface="Courier New" pitchFamily="34" charset="0"/>
+                <a:ea typeface="Courier New" pitchFamily="34" charset="-122"/>
+                <a:cs typeface="Courier New" pitchFamily="34" charset="-120"/>
               </a:rPr>
               <a:t>8 步审计闭环架构</a:t>
             </a:r>
@@ -3124,7 +3124,7 @@
             <a:r>
               <a:rPr lang="en-US" sz="1000" dirty="0">
                 <a:solidFill>
-                  <a:srgbClr val="888888"/>
+                  <a:srgbClr val="666666"/>
                 </a:solidFill>
               </a:rPr>
               <a:t>Athena · Z.AI Hackathon · GLM-5.1</a:t>
@@ -3147,7 +3147,7 @@
     <p:bg>
       <p:bgPr>
         <a:solidFill>
-          <a:srgbClr val="0A0A0A"/>
+          <a:srgbClr val="000000"/>
         </a:solidFill>
       </p:bgPr>
     </p:bg>
@@ -3194,9 +3194,9 @@
                 <a:solidFill>
                   <a:srgbClr val="FFFFFF"/>
                 </a:solidFill>
-                <a:latin typeface="Arial" pitchFamily="34" charset="0"/>
-                <a:ea typeface="Arial" pitchFamily="34" charset="-122"/>
-                <a:cs typeface="Arial" pitchFamily="34" charset="-120"/>
+                <a:latin typeface="Courier New" pitchFamily="34" charset="0"/>
+                <a:ea typeface="Courier New" pitchFamily="34" charset="-122"/>
+                <a:cs typeface="Courier New" pitchFamily="34" charset="-120"/>
               </a:rPr>
               <a:t>12 Agent 审计 Skill</a:t>
             </a:r>
@@ -3255,7 +3255,7 @@
             <a:r>
               <a:rPr lang="en-US" sz="1000" dirty="0">
                 <a:solidFill>
-                  <a:srgbClr val="888888"/>
+                  <a:srgbClr val="666666"/>
                 </a:solidFill>
               </a:rPr>
               <a:t>Athena · Z.AI Hackathon · GLM-5.1</a:t>
@@ -3278,7 +3278,7 @@
     <p:bg>
       <p:bgPr>
         <a:solidFill>
-          <a:srgbClr val="0A0A0A"/>
+          <a:srgbClr val="000000"/>
         </a:solidFill>
       </p:bgPr>
     </p:bg>
@@ -3325,9 +3325,9 @@
                 <a:solidFill>
                   <a:srgbClr val="FFFFFF"/>
                 </a:solidFill>
-                <a:latin typeface="Arial" pitchFamily="34" charset="0"/>
-                <a:ea typeface="Arial" pitchFamily="34" charset="-122"/>
-                <a:cs typeface="Arial" pitchFamily="34" charset="-120"/>
+                <a:latin typeface="Courier New" pitchFamily="34" charset="0"/>
+                <a:ea typeface="Courier New" pitchFamily="34" charset="-122"/>
+                <a:cs typeface="Courier New" pitchFamily="34" charset="-120"/>
               </a:rPr>
               <a:t>13 MCP 工具</a:t>
             </a:r>
@@ -3386,7 +3386,7 @@
             <a:r>
               <a:rPr lang="en-US" sz="1000" dirty="0">
                 <a:solidFill>
-                  <a:srgbClr val="888888"/>
+                  <a:srgbClr val="666666"/>
                 </a:solidFill>
               </a:rPr>
               <a:t>Athena · Z.AI Hackathon · GLM-5.1</a:t>
@@ -3409,7 +3409,7 @@
     <p:bg>
       <p:bgPr>
         <a:solidFill>
-          <a:srgbClr val="0A0A0A"/>
+          <a:srgbClr val="000000"/>
         </a:solidFill>
       </p:bgPr>
     </p:bg>
@@ -3456,9 +3456,9 @@
                 <a:solidFill>
                   <a:srgbClr val="FFFFFF"/>
                 </a:solidFill>
-                <a:latin typeface="Arial" pitchFamily="34" charset="0"/>
-                <a:ea typeface="Arial" pitchFamily="34" charset="-122"/>
-                <a:cs typeface="Arial" pitchFamily="34" charset="-120"/>
+                <a:latin typeface="Courier New" pitchFamily="34" charset="0"/>
+                <a:ea typeface="Courier New" pitchFamily="34" charset="-122"/>
+                <a:cs typeface="Courier New" pitchFamily="34" charset="-120"/>
               </a:rPr>
               <a:t>审计报告 + 链上验证</a:t>
             </a:r>
@@ -3481,11 +3481,11 @@
             <a:avLst/>
           </a:prstGeom>
           <a:solidFill>
-            <a:srgbClr val="1A1F3A"/>
+            <a:srgbClr val="0A0A0A"/>
           </a:solidFill>
           <a:ln w="12700">
             <a:solidFill>
-              <a:srgbClr val="4A90D9"/>
+              <a:srgbClr val="333333"/>
             </a:solidFill>
             <a:prstDash val="solid"/>
           </a:ln>
@@ -3518,11 +3518,11 @@
             <a:r>
               <a:rPr lang="en-US" sz="1400" b="1" dirty="0">
                 <a:solidFill>
-                  <a:srgbClr val="4A90D9"/>
-                </a:solidFill>
-                <a:latin typeface="Arial" pitchFamily="34" charset="0"/>
-                <a:ea typeface="Arial" pitchFamily="34" charset="-122"/>
-                <a:cs typeface="Arial" pitchFamily="34" charset="-120"/>
+                  <a:srgbClr val="333333"/>
+                </a:solidFill>
+                <a:latin typeface="Courier New" pitchFamily="34" charset="0"/>
+                <a:ea typeface="Courier New" pitchFamily="34" charset="-122"/>
+                <a:cs typeface="Courier New" pitchFamily="34" charset="-120"/>
               </a:rPr>
               <a:t>审计报告：DeFi Protocol</a:t>
             </a:r>
@@ -3557,11 +3557,11 @@
             <a:r>
               <a:rPr lang="en-US" sz="1000" b="1" dirty="0">
                 <a:solidFill>
-                  <a:srgbClr val="FF0000"/>
-                </a:solidFill>
-                <a:latin typeface="Arial" pitchFamily="34" charset="0"/>
-                <a:ea typeface="Arial" pitchFamily="34" charset="-122"/>
-                <a:cs typeface="Arial" pitchFamily="34" charset="-120"/>
+                  <a:srgbClr val="888888"/>
+                </a:solidFill>
+                <a:latin typeface="Courier New" pitchFamily="34" charset="0"/>
+                <a:ea typeface="Courier New" pitchFamily="34" charset="-122"/>
+                <a:cs typeface="Courier New" pitchFamily="34" charset="-120"/>
               </a:rPr>
               <a:t>安全评分：2/10</a:t>
             </a:r>
@@ -3580,13 +3580,30 @@
             <a:r>
               <a:rPr lang="en-US" sz="1000" b="1" dirty="0">
                 <a:solidFill>
+                  <a:srgbClr val="666666"/>
+                </a:solidFill>
+                <a:latin typeface="Courier New" pitchFamily="34" charset="0"/>
+                <a:ea typeface="Courier New" pitchFamily="34" charset="-122"/>
+                <a:cs typeface="Courier New" pitchFamily="34" charset="-120"/>
+              </a:rPr>
+              <a:t>漏洞发现（5 个）：</a:t>
+            </a:r>
+            <a:endParaRPr lang="en-US" sz="1000" dirty="0"/>
+          </a:p>
+          <a:p>
+            <a:pPr algn="l" indent="0" marL="0">
+              <a:buNone/>
+            </a:pPr>
+            <a:r>
+              <a:rPr lang="en-US" sz="1000" dirty="0">
+                <a:solidFill>
                   <a:srgbClr val="888888"/>
                 </a:solidFill>
-                <a:latin typeface="Arial" pitchFamily="34" charset="0"/>
-                <a:ea typeface="Arial" pitchFamily="34" charset="-122"/>
-                <a:cs typeface="Arial" pitchFamily="34" charset="-120"/>
-              </a:rPr>
-              <a:t>漏洞发现（5 个）：</a:t>
+                <a:latin typeface="Courier New" pitchFamily="34" charset="0"/>
+                <a:ea typeface="Courier New" pitchFamily="34" charset="-122"/>
+                <a:cs typeface="Courier New" pitchFamily="34" charset="-120"/>
+              </a:rPr>
+              <a:t>● Critical: Reentrancy (Vault.withdraw) 95%</a:t>
             </a:r>
             <a:endParaRPr lang="en-US" sz="1000" dirty="0"/>
           </a:p>
@@ -3597,13 +3614,13 @@
             <a:r>
               <a:rPr lang="en-US" sz="1000" dirty="0">
                 <a:solidFill>
-                  <a:srgbClr val="FF0000"/>
-                </a:solidFill>
-                <a:latin typeface="Arial" pitchFamily="34" charset="0"/>
-                <a:ea typeface="Arial" pitchFamily="34" charset="-122"/>
-                <a:cs typeface="Arial" pitchFamily="34" charset="-120"/>
-              </a:rPr>
-              <a:t>● Critical: Reentrancy (Vault.withdraw) 95%</a:t>
+                  <a:srgbClr val="888888"/>
+                </a:solidFill>
+                <a:latin typeface="Courier New" pitchFamily="34" charset="0"/>
+                <a:ea typeface="Courier New" pitchFamily="34" charset="-122"/>
+                <a:cs typeface="Courier New" pitchFamily="34" charset="-120"/>
+              </a:rPr>
+              <a:t>● High: Oracle 价格操纵 90%</a:t>
             </a:r>
             <a:endParaRPr lang="en-US" sz="1000" dirty="0"/>
           </a:p>
@@ -3614,13 +3631,13 @@
             <a:r>
               <a:rPr lang="en-US" sz="1000" dirty="0">
                 <a:solidFill>
-                  <a:srgbClr val="FF8800"/>
-                </a:solidFill>
-                <a:latin typeface="Arial" pitchFamily="34" charset="0"/>
-                <a:ea typeface="Arial" pitchFamily="34" charset="-122"/>
-                <a:cs typeface="Arial" pitchFamily="34" charset="-120"/>
-              </a:rPr>
-              <a:t>● High: Oracle 价格操纵 90%</a:t>
+                  <a:srgbClr val="888888"/>
+                </a:solidFill>
+                <a:latin typeface="Courier New" pitchFamily="34" charset="0"/>
+                <a:ea typeface="Courier New" pitchFamily="34" charset="-122"/>
+                <a:cs typeface="Courier New" pitchFamily="34" charset="-120"/>
+              </a:rPr>
+              <a:t>● High: 缺少访问控制 88%</a:t>
             </a:r>
             <a:endParaRPr lang="en-US" sz="1000" dirty="0"/>
           </a:p>
@@ -3631,13 +3648,13 @@
             <a:r>
               <a:rPr lang="en-US" sz="1000" dirty="0">
                 <a:solidFill>
-                  <a:srgbClr val="FF8800"/>
-                </a:solidFill>
-                <a:latin typeface="Arial" pitchFamily="34" charset="0"/>
-                <a:ea typeface="Arial" pitchFamily="34" charset="-122"/>
-                <a:cs typeface="Arial" pitchFamily="34" charset="-120"/>
-              </a:rPr>
-              <a:t>● High: 缺少访问控制 88%</a:t>
+                  <a:srgbClr val="888888"/>
+                </a:solidFill>
+                <a:latin typeface="Courier New" pitchFamily="34" charset="0"/>
+                <a:ea typeface="Courier New" pitchFamily="34" charset="-122"/>
+                <a:cs typeface="Courier New" pitchFamily="34" charset="-120"/>
+              </a:rPr>
+              <a:t>● Medium: 整数溢出 80%</a:t>
             </a:r>
             <a:endParaRPr lang="en-US" sz="1000" dirty="0"/>
           </a:p>
@@ -3648,13 +3665,13 @@
             <a:r>
               <a:rPr lang="en-US" sz="1000" dirty="0">
                 <a:solidFill>
-                  <a:srgbClr val="FFFF00"/>
-                </a:solidFill>
-                <a:latin typeface="Arial" pitchFamily="34" charset="0"/>
-                <a:ea typeface="Arial" pitchFamily="34" charset="-122"/>
-                <a:cs typeface="Arial" pitchFamily="34" charset="-120"/>
-              </a:rPr>
-              <a:t>● Medium: 整数溢出 80%</a:t>
+                  <a:srgbClr val="888888"/>
+                </a:solidFill>
+                <a:latin typeface="Courier New" pitchFamily="34" charset="0"/>
+                <a:ea typeface="Courier New" pitchFamily="34" charset="-122"/>
+                <a:cs typeface="Courier New" pitchFamily="34" charset="-120"/>
+              </a:rPr>
+              <a:t>● Low: 未初始化存储 70%</a:t>
             </a:r>
             <a:endParaRPr lang="en-US" sz="1000" dirty="0"/>
           </a:p>
@@ -3662,16 +3679,22 @@
             <a:pPr algn="l" indent="0" marL="0">
               <a:buNone/>
             </a:pPr>
+            <a:endParaRPr lang="en-US" sz="1000" dirty="0"/>
+          </a:p>
+          <a:p>
+            <a:pPr algn="l" indent="0" marL="0">
+              <a:buNone/>
+            </a:pPr>
             <a:r>
               <a:rPr lang="en-US" sz="1000" dirty="0">
                 <a:solidFill>
-                  <a:srgbClr val="0088FF"/>
-                </a:solidFill>
-                <a:latin typeface="Arial" pitchFamily="34" charset="0"/>
-                <a:ea typeface="Arial" pitchFamily="34" charset="-122"/>
-                <a:cs typeface="Arial" pitchFamily="34" charset="-120"/>
-              </a:rPr>
-              <a:t>● Low: 未初始化存储 70%</a:t>
+                  <a:srgbClr val="666666"/>
+                </a:solidFill>
+                <a:latin typeface="Courier New" pitchFamily="34" charset="0"/>
+                <a:ea typeface="Courier New" pitchFamily="34" charset="-122"/>
+                <a:cs typeface="Courier New" pitchFamily="34" charset="-120"/>
+              </a:rPr>
+              <a:t>攻击模拟：$2.3M 预计损失</a:t>
             </a:r>
             <a:endParaRPr lang="en-US" sz="1000" dirty="0"/>
           </a:p>
@@ -3679,37 +3702,14 @@
             <a:pPr algn="l" indent="0" marL="0">
               <a:buNone/>
             </a:pPr>
-            <a:endParaRPr lang="en-US" sz="1000" dirty="0"/>
-          </a:p>
-          <a:p>
-            <a:pPr algn="l" indent="0" marL="0">
-              <a:buNone/>
-            </a:pPr>
             <a:r>
               <a:rPr lang="en-US" sz="1000" dirty="0">
                 <a:solidFill>
-                  <a:srgbClr val="888888"/>
-                </a:solidFill>
-                <a:latin typeface="Arial" pitchFamily="34" charset="0"/>
-                <a:ea typeface="Arial" pitchFamily="34" charset="-122"/>
-                <a:cs typeface="Arial" pitchFamily="34" charset="-120"/>
-              </a:rPr>
-              <a:t>攻击模拟：$2.3M 预计损失</a:t>
-            </a:r>
-            <a:endParaRPr lang="en-US" sz="1000" dirty="0"/>
-          </a:p>
-          <a:p>
-            <a:pPr algn="l" indent="0" marL="0">
-              <a:buNone/>
-            </a:pPr>
-            <a:r>
-              <a:rPr lang="en-US" sz="1000" dirty="0">
-                <a:solidFill>
-                  <a:srgbClr val="888888"/>
-                </a:solidFill>
-                <a:latin typeface="Arial" pitchFamily="34" charset="0"/>
-                <a:ea typeface="Arial" pitchFamily="34" charset="-122"/>
-                <a:cs typeface="Arial" pitchFamily="34" charset="-120"/>
+                  <a:srgbClr val="666666"/>
+                </a:solidFill>
+                <a:latin typeface="Courier New" pitchFamily="34" charset="0"/>
+                <a:ea typeface="Courier New" pitchFamily="34" charset="-122"/>
+                <a:cs typeface="Courier New" pitchFamily="34" charset="-120"/>
               </a:rPr>
               <a:t>PoC 验证：Foundry 256 runs ✓</a:t>
             </a:r>
@@ -3732,7 +3732,7 @@
             <a:avLst/>
           </a:prstGeom>
           <a:solidFill>
-            <a:srgbClr val="1A1F3A"/>
+            <a:srgbClr val="0A0A0A"/>
           </a:solidFill>
           <a:ln w="25400">
             <a:solidFill>
@@ -3771,9 +3771,9 @@
                 <a:solidFill>
                   <a:srgbClr val="D4A535"/>
                 </a:solidFill>
-                <a:latin typeface="Arial" pitchFamily="34" charset="0"/>
-                <a:ea typeface="Arial" pitchFamily="34" charset="-122"/>
-                <a:cs typeface="Arial" pitchFamily="34" charset="-120"/>
+                <a:latin typeface="Courier New" pitchFamily="34" charset="0"/>
+                <a:ea typeface="Courier New" pitchFamily="34" charset="-122"/>
+                <a:cs typeface="Courier New" pitchFamily="34" charset="-120"/>
               </a:rPr>
               <a:t>链上认证（EAS）</a:t>
             </a:r>
@@ -3808,11 +3808,11 @@
             <a:r>
               <a:rPr lang="en-US" sz="1100" dirty="0">
                 <a:solidFill>
-                  <a:srgbClr val="00FF00"/>
-                </a:solidFill>
-                <a:latin typeface="Arial" pitchFamily="34" charset="0"/>
-                <a:ea typeface="Arial" pitchFamily="34" charset="-122"/>
-                <a:cs typeface="Arial" pitchFamily="34" charset="-120"/>
+                  <a:srgbClr val="888888"/>
+                </a:solidFill>
+                <a:latin typeface="Courier New" pitchFamily="34" charset="0"/>
+                <a:ea typeface="Courier New" pitchFamily="34" charset="-122"/>
+                <a:cs typeface="Courier New" pitchFamily="34" charset="-120"/>
               </a:rPr>
               <a:t>✓ 不可篡改 · 可验证 · 可追溯</a:t>
             </a:r>
@@ -3831,11 +3831,11 @@
             <a:r>
               <a:rPr lang="en-US" sz="1100" b="1" dirty="0">
                 <a:solidFill>
-                  <a:srgbClr val="00FF00"/>
-                </a:solidFill>
-                <a:latin typeface="Arial" pitchFamily="34" charset="0"/>
-                <a:ea typeface="Arial" pitchFamily="34" charset="-122"/>
-                <a:cs typeface="Arial" pitchFamily="34" charset="-120"/>
+                  <a:srgbClr val="888888"/>
+                </a:solidFill>
+                <a:latin typeface="Courier New" pitchFamily="34" charset="0"/>
+                <a:ea typeface="Courier New" pitchFamily="34" charset="-122"/>
+                <a:cs typeface="Courier New" pitchFamily="34" charset="-120"/>
               </a:rPr>
               <a:t>EAS Attestation UID:</a:t>
             </a:r>
@@ -3848,11 +3848,11 @@
             <a:r>
               <a:rPr lang="en-US" sz="1100" dirty="0">
                 <a:solidFill>
-                  <a:srgbClr val="00FF00"/>
-                </a:solidFill>
-                <a:latin typeface="Arial" pitchFamily="34" charset="0"/>
-                <a:ea typeface="Arial" pitchFamily="34" charset="-122"/>
-                <a:cs typeface="Arial" pitchFamily="34" charset="-120"/>
+                  <a:srgbClr val="888888"/>
+                </a:solidFill>
+                <a:latin typeface="Courier New" pitchFamily="34" charset="0"/>
+                <a:ea typeface="Courier New" pitchFamily="34" charset="-122"/>
+                <a:cs typeface="Courier New" pitchFamily="34" charset="-120"/>
               </a:rPr>
               <a:t>0xd02800c960f18f...</a:t>
             </a:r>
@@ -3871,11 +3871,11 @@
             <a:r>
               <a:rPr lang="en-US" sz="1100" dirty="0">
                 <a:solidFill>
-                  <a:srgbClr val="00FF00"/>
-                </a:solidFill>
-                <a:latin typeface="Arial" pitchFamily="34" charset="0"/>
-                <a:ea typeface="Arial" pitchFamily="34" charset="-122"/>
-                <a:cs typeface="Arial" pitchFamily="34" charset="-120"/>
+                  <a:srgbClr val="888888"/>
+                </a:solidFill>
+                <a:latin typeface="Courier New" pitchFamily="34" charset="0"/>
+                <a:ea typeface="Courier New" pitchFamily="34" charset="-122"/>
+                <a:cs typeface="Courier New" pitchFamily="34" charset="-120"/>
               </a:rPr>
               <a:t>合约：0x3247d57d...</a:t>
             </a:r>
@@ -3894,11 +3894,11 @@
             <a:r>
               <a:rPr lang="en-US" sz="1100" dirty="0">
                 <a:solidFill>
-                  <a:srgbClr val="00FF00"/>
-                </a:solidFill>
-                <a:latin typeface="Arial" pitchFamily="34" charset="0"/>
-                <a:ea typeface="Arial" pitchFamily="34" charset="-122"/>
-                <a:cs typeface="Arial" pitchFamily="34" charset="-120"/>
+                  <a:srgbClr val="888888"/>
+                </a:solidFill>
+                <a:latin typeface="Courier New" pitchFamily="34" charset="0"/>
+                <a:ea typeface="Courier New" pitchFamily="34" charset="-122"/>
+                <a:cs typeface="Courier New" pitchFamily="34" charset="-120"/>
               </a:rPr>
               <a:t>Sepolia 测试网</a:t>
             </a:r>
@@ -3911,11 +3911,11 @@
             <a:r>
               <a:rPr lang="en-US" sz="1100" dirty="0">
                 <a:solidFill>
-                  <a:srgbClr val="00FF00"/>
-                </a:solidFill>
-                <a:latin typeface="Arial" pitchFamily="34" charset="0"/>
-                <a:ea typeface="Arial" pitchFamily="34" charset="-122"/>
-                <a:cs typeface="Arial" pitchFamily="34" charset="-120"/>
+                  <a:srgbClr val="888888"/>
+                </a:solidFill>
+                <a:latin typeface="Courier New" pitchFamily="34" charset="0"/>
+                <a:ea typeface="Courier New" pitchFamily="34" charset="-122"/>
+                <a:cs typeface="Courier New" pitchFamily="34" charset="-120"/>
               </a:rPr>
               <a:t>零成本验证</a:t>
             </a:r>
@@ -3934,11 +3934,11 @@
             <a:r>
               <a:rPr lang="en-US" sz="1100" dirty="0">
                 <a:solidFill>
-                  <a:srgbClr val="4A90D9"/>
-                </a:solidFill>
-                <a:latin typeface="Arial" pitchFamily="34" charset="0"/>
-                <a:ea typeface="Arial" pitchFamily="34" charset="-122"/>
-                <a:cs typeface="Arial" pitchFamily="34" charset="-120"/>
+                  <a:srgbClr val="333333"/>
+                </a:solidFill>
+                <a:latin typeface="Courier New" pitchFamily="34" charset="0"/>
+                <a:ea typeface="Courier New" pitchFamily="34" charset="-122"/>
+                <a:cs typeface="Courier New" pitchFamily="34" charset="-120"/>
               </a:rPr>
               <a:t>查看验证 →</a:t>
             </a:r>
@@ -3951,11 +3951,11 @@
             <a:r>
               <a:rPr lang="en-US" sz="800" dirty="0">
                 <a:solidFill>
-                  <a:srgbClr val="4A90D9"/>
-                </a:solidFill>
-                <a:latin typeface="Arial" pitchFamily="34" charset="0"/>
-                <a:ea typeface="Arial" pitchFamily="34" charset="-122"/>
-                <a:cs typeface="Arial" pitchFamily="34" charset="-120"/>
+                  <a:srgbClr val="333333"/>
+                </a:solidFill>
+                <a:latin typeface="Courier New" pitchFamily="34" charset="0"/>
+                <a:ea typeface="Courier New" pitchFamily="34" charset="-122"/>
+                <a:cs typeface="Courier New" pitchFamily="34" charset="-120"/>
               </a:rPr>
               <a:t>sepolia.easscan.org</a:t>
             </a:r>
@@ -3990,7 +3990,7 @@
             <a:r>
               <a:rPr lang="en-US" sz="1000" dirty="0">
                 <a:solidFill>
-                  <a:srgbClr val="888888"/>
+                  <a:srgbClr val="666666"/>
                 </a:solidFill>
               </a:rPr>
               <a:t>Athena · Z.AI Hackathon · GLM-5.1</a:t>
@@ -4013,7 +4013,7 @@
     <p:bg>
       <p:bgPr>
         <a:solidFill>
-          <a:srgbClr val="0A0A0A"/>
+          <a:srgbClr val="000000"/>
         </a:solidFill>
       </p:bgPr>
     </p:bg>
@@ -4060,9 +4060,9 @@
                 <a:solidFill>
                   <a:srgbClr val="FFFFFF"/>
                 </a:solidFill>
-                <a:latin typeface="Arial" pitchFamily="34" charset="0"/>
-                <a:ea typeface="Arial" pitchFamily="34" charset="-122"/>
-                <a:cs typeface="Arial" pitchFamily="34" charset="-120"/>
+                <a:latin typeface="Courier New" pitchFamily="34" charset="0"/>
+                <a:ea typeface="Courier New" pitchFamily="34" charset="-122"/>
+                <a:cs typeface="Courier New" pitchFamily="34" charset="-120"/>
               </a:rPr>
               <a:t>Generative NFT 审计证书</a:t>
             </a:r>
@@ -4123,9 +4123,9 @@
                 <a:solidFill>
                   <a:srgbClr val="D4A535"/>
                 </a:solidFill>
-                <a:latin typeface="Arial" pitchFamily="34" charset="0"/>
-                <a:ea typeface="Arial" pitchFamily="34" charset="-122"/>
-                <a:cs typeface="Arial" pitchFamily="34" charset="-120"/>
+                <a:latin typeface="Courier New" pitchFamily="34" charset="0"/>
+                <a:ea typeface="Courier New" pitchFamily="34" charset="-122"/>
+                <a:cs typeface="Courier New" pitchFamily="34" charset="-120"/>
               </a:rPr>
               <a:t>S-TIER · Gold NFT</a:t>
             </a:r>
@@ -4148,7 +4148,7 @@
             <a:avLst/>
           </a:prstGeom>
           <a:solidFill>
-            <a:srgbClr val="1A1F3A"/>
+            <a:srgbClr val="0A0A0A"/>
           </a:solidFill>
           <a:ln w="12700">
             <a:solidFill>
@@ -4187,9 +4187,9 @@
                 <a:solidFill>
                   <a:srgbClr val="D4A535"/>
                 </a:solidFill>
-                <a:latin typeface="Arial" pitchFamily="34" charset="0"/>
-                <a:ea typeface="Arial" pitchFamily="34" charset="-122"/>
-                <a:cs typeface="Arial" pitchFamily="34" charset="-120"/>
+                <a:latin typeface="Courier New" pitchFamily="34" charset="0"/>
+                <a:ea typeface="Courier New" pitchFamily="34" charset="-122"/>
+                <a:cs typeface="Courier New" pitchFamily="34" charset="-120"/>
               </a:rPr>
               <a:t>12,064</a:t>
             </a:r>
@@ -4202,91 +4202,91 @@
             <a:r>
               <a:rPr lang="en-US" sz="1000" dirty="0">
                 <a:solidFill>
+                  <a:srgbClr val="666666"/>
+                </a:solidFill>
+                <a:latin typeface="Courier New" pitchFamily="34" charset="0"/>
+                <a:ea typeface="Courier New" pitchFamily="34" charset="-122"/>
+                <a:cs typeface="Courier New" pitchFamily="34" charset="-120"/>
+              </a:rPr>
+              <a:t>Trait 组合</a:t>
+            </a:r>
+            <a:endParaRPr lang="en-US" sz="2000" dirty="0"/>
+          </a:p>
+          <a:p>
+            <a:pPr algn="ctr" indent="0" marL="0">
+              <a:buNone/>
+            </a:pPr>
+            <a:endParaRPr lang="en-US" sz="2000" dirty="0"/>
+          </a:p>
+          <a:p>
+            <a:pPr algn="ctr" indent="0" marL="0">
+              <a:buNone/>
+            </a:pPr>
+            <a:r>
+              <a:rPr lang="en-US" sz="1200" b="1" dirty="0">
+                <a:solidFill>
+                  <a:srgbClr val="FFFFFF"/>
+                </a:solidFill>
+                <a:latin typeface="Courier New" pitchFamily="34" charset="0"/>
+                <a:ea typeface="Courier New" pitchFamily="34" charset="-122"/>
+                <a:cs typeface="Courier New" pitchFamily="34" charset="-120"/>
+              </a:rPr>
+              <a:t>S/A/B/C 四级</a:t>
+            </a:r>
+            <a:endParaRPr lang="en-US" sz="2000" dirty="0"/>
+          </a:p>
+          <a:p>
+            <a:pPr algn="ctr" indent="0" marL="0">
+              <a:buNone/>
+            </a:pPr>
+            <a:r>
+              <a:rPr lang="en-US" sz="1000" dirty="0">
+                <a:solidFill>
+                  <a:srgbClr val="666666"/>
+                </a:solidFill>
+                <a:latin typeface="Courier New" pitchFamily="34" charset="0"/>
+                <a:ea typeface="Courier New" pitchFamily="34" charset="-122"/>
+                <a:cs typeface="Courier New" pitchFamily="34" charset="-120"/>
+              </a:rPr>
+              <a:t>OpenRarity 算法</a:t>
+            </a:r>
+            <a:endParaRPr lang="en-US" sz="2000" dirty="0"/>
+          </a:p>
+          <a:p>
+            <a:pPr algn="ctr" indent="0" marL="0">
+              <a:buNone/>
+            </a:pPr>
+            <a:endParaRPr lang="en-US" sz="2000" dirty="0"/>
+          </a:p>
+          <a:p>
+            <a:pPr algn="ctr" indent="0" marL="0">
+              <a:buNone/>
+            </a:pPr>
+            <a:r>
+              <a:rPr lang="en-US" sz="1200" b="1" dirty="0">
+                <a:solidFill>
+                  <a:srgbClr val="D4A535"/>
+                </a:solidFill>
+                <a:latin typeface="Courier New" pitchFamily="34" charset="0"/>
+                <a:ea typeface="Courier New" pitchFamily="34" charset="-122"/>
+                <a:cs typeface="Courier New" pitchFamily="34" charset="-120"/>
+              </a:rPr>
+              <a:t>Token #1</a:t>
+            </a:r>
+            <a:endParaRPr lang="en-US" sz="2000" dirty="0"/>
+          </a:p>
+          <a:p>
+            <a:pPr algn="ctr" indent="0" marL="0">
+              <a:buNone/>
+            </a:pPr>
+            <a:r>
+              <a:rPr lang="en-US" sz="1000" dirty="0">
+                <a:solidFill>
                   <a:srgbClr val="888888"/>
                 </a:solidFill>
-                <a:latin typeface="Arial" pitchFamily="34" charset="0"/>
-                <a:ea typeface="Arial" pitchFamily="34" charset="-122"/>
-                <a:cs typeface="Arial" pitchFamily="34" charset="-120"/>
-              </a:rPr>
-              <a:t>Trait 组合</a:t>
-            </a:r>
-            <a:endParaRPr lang="en-US" sz="2000" dirty="0"/>
-          </a:p>
-          <a:p>
-            <a:pPr algn="ctr" indent="0" marL="0">
-              <a:buNone/>
-            </a:pPr>
-            <a:endParaRPr lang="en-US" sz="2000" dirty="0"/>
-          </a:p>
-          <a:p>
-            <a:pPr algn="ctr" indent="0" marL="0">
-              <a:buNone/>
-            </a:pPr>
-            <a:r>
-              <a:rPr lang="en-US" sz="1200" b="1" dirty="0">
-                <a:solidFill>
-                  <a:srgbClr val="FFFFFF"/>
-                </a:solidFill>
-                <a:latin typeface="Arial" pitchFamily="34" charset="0"/>
-                <a:ea typeface="Arial" pitchFamily="34" charset="-122"/>
-                <a:cs typeface="Arial" pitchFamily="34" charset="-120"/>
-              </a:rPr>
-              <a:t>S/A/B/C 四级</a:t>
-            </a:r>
-            <a:endParaRPr lang="en-US" sz="2000" dirty="0"/>
-          </a:p>
-          <a:p>
-            <a:pPr algn="ctr" indent="0" marL="0">
-              <a:buNone/>
-            </a:pPr>
-            <a:r>
-              <a:rPr lang="en-US" sz="1000" dirty="0">
-                <a:solidFill>
-                  <a:srgbClr val="888888"/>
-                </a:solidFill>
-                <a:latin typeface="Arial" pitchFamily="34" charset="0"/>
-                <a:ea typeface="Arial" pitchFamily="34" charset="-122"/>
-                <a:cs typeface="Arial" pitchFamily="34" charset="-120"/>
-              </a:rPr>
-              <a:t>OpenRarity 算法</a:t>
-            </a:r>
-            <a:endParaRPr lang="en-US" sz="2000" dirty="0"/>
-          </a:p>
-          <a:p>
-            <a:pPr algn="ctr" indent="0" marL="0">
-              <a:buNone/>
-            </a:pPr>
-            <a:endParaRPr lang="en-US" sz="2000" dirty="0"/>
-          </a:p>
-          <a:p>
-            <a:pPr algn="ctr" indent="0" marL="0">
-              <a:buNone/>
-            </a:pPr>
-            <a:r>
-              <a:rPr lang="en-US" sz="1200" b="1" dirty="0">
-                <a:solidFill>
-                  <a:srgbClr val="D4A535"/>
-                </a:solidFill>
-                <a:latin typeface="Arial" pitchFamily="34" charset="0"/>
-                <a:ea typeface="Arial" pitchFamily="34" charset="-122"/>
-                <a:cs typeface="Arial" pitchFamily="34" charset="-120"/>
-              </a:rPr>
-              <a:t>Token #1</a:t>
-            </a:r>
-            <a:endParaRPr lang="en-US" sz="2000" dirty="0"/>
-          </a:p>
-          <a:p>
-            <a:pPr algn="ctr" indent="0" marL="0">
-              <a:buNone/>
-            </a:pPr>
-            <a:r>
-              <a:rPr lang="en-US" sz="1000" dirty="0">
-                <a:solidFill>
-                  <a:srgbClr val="00FF00"/>
-                </a:solidFill>
-                <a:latin typeface="Arial" pitchFamily="34" charset="0"/>
-                <a:ea typeface="Arial" pitchFamily="34" charset="-122"/>
-                <a:cs typeface="Arial" pitchFamily="34" charset="-120"/>
+                <a:latin typeface="Courier New" pitchFamily="34" charset="0"/>
+                <a:ea typeface="Courier New" pitchFamily="34" charset="-122"/>
+                <a:cs typeface="Courier New" pitchFamily="34" charset="-120"/>
               </a:rPr>
               <a:t>已铸造</a:t>
             </a:r>
@@ -4309,11 +4309,11 @@
             <a:avLst/>
           </a:prstGeom>
           <a:solidFill>
-            <a:srgbClr val="1A1F3A"/>
+            <a:srgbClr val="0A0A0A"/>
           </a:solidFill>
           <a:ln w="12700">
             <a:solidFill>
-              <a:srgbClr val="4A90D9"/>
+              <a:srgbClr val="333333"/>
             </a:solidFill>
             <a:prstDash val="solid"/>
           </a:ln>
@@ -4346,11 +4346,11 @@
             <a:r>
               <a:rPr lang="en-US" sz="1400" b="1" dirty="0">
                 <a:solidFill>
-                  <a:srgbClr val="4A90D9"/>
-                </a:solidFill>
-                <a:latin typeface="Consolas" pitchFamily="34" charset="0"/>
-                <a:ea typeface="Consolas" pitchFamily="34" charset="-122"/>
-                <a:cs typeface="Consolas" pitchFamily="34" charset="-120"/>
+                  <a:srgbClr val="333333"/>
+                </a:solidFill>
+                <a:latin typeface="Courier New" pitchFamily="34" charset="0"/>
+                <a:ea typeface="Courier New" pitchFamily="34" charset="-122"/>
+                <a:cs typeface="Courier New" pitchFamily="34" charset="-120"/>
               </a:rPr>
               <a:t>Sepolia</a:t>
             </a:r>
@@ -4369,11 +4369,11 @@
             <a:r>
               <a:rPr lang="en-US" sz="1000" dirty="0">
                 <a:solidFill>
-                  <a:srgbClr val="888888"/>
-                </a:solidFill>
-                <a:latin typeface="Consolas" pitchFamily="34" charset="0"/>
-                <a:ea typeface="Consolas" pitchFamily="34" charset="-122"/>
-                <a:cs typeface="Consolas" pitchFamily="34" charset="-120"/>
+                  <a:srgbClr val="666666"/>
+                </a:solidFill>
+                <a:latin typeface="Courier New" pitchFamily="34" charset="0"/>
+                <a:ea typeface="Courier New" pitchFamily="34" charset="-122"/>
+                <a:cs typeface="Courier New" pitchFamily="34" charset="-120"/>
               </a:rPr>
               <a:t>ERC-1155</a:t>
             </a:r>
@@ -4386,11 +4386,11 @@
             <a:r>
               <a:rPr lang="en-US" sz="1000" dirty="0">
                 <a:solidFill>
-                  <a:srgbClr val="888888"/>
-                </a:solidFill>
-                <a:latin typeface="Consolas" pitchFamily="34" charset="0"/>
-                <a:ea typeface="Consolas" pitchFamily="34" charset="-122"/>
-                <a:cs typeface="Consolas" pitchFamily="34" charset="-120"/>
+                  <a:srgbClr val="666666"/>
+                </a:solidFill>
+                <a:latin typeface="Courier New" pitchFamily="34" charset="0"/>
+                <a:ea typeface="Courier New" pitchFamily="34" charset="-122"/>
+                <a:cs typeface="Courier New" pitchFamily="34" charset="-120"/>
               </a:rPr>
               <a:t>ERC-20 ART</a:t>
             </a:r>
@@ -4403,11 +4403,11 @@
             <a:r>
               <a:rPr lang="en-US" sz="1000" dirty="0">
                 <a:solidFill>
-                  <a:srgbClr val="888888"/>
-                </a:solidFill>
-                <a:latin typeface="Consolas" pitchFamily="34" charset="0"/>
-                <a:ea typeface="Consolas" pitchFamily="34" charset="-122"/>
-                <a:cs typeface="Consolas" pitchFamily="34" charset="-120"/>
+                  <a:srgbClr val="666666"/>
+                </a:solidFill>
+                <a:latin typeface="Courier New" pitchFamily="34" charset="0"/>
+                <a:ea typeface="Courier New" pitchFamily="34" charset="-122"/>
+                <a:cs typeface="Courier New" pitchFamily="34" charset="-120"/>
               </a:rPr>
               <a:t>EAS 认证</a:t>
             </a:r>
@@ -4426,11 +4426,11 @@
             <a:r>
               <a:rPr lang="en-US" sz="800" dirty="0">
                 <a:solidFill>
-                  <a:srgbClr val="888888"/>
-                </a:solidFill>
-                <a:latin typeface="Consolas" pitchFamily="34" charset="0"/>
-                <a:ea typeface="Consolas" pitchFamily="34" charset="-122"/>
-                <a:cs typeface="Consolas" pitchFamily="34" charset="-120"/>
+                  <a:srgbClr val="666666"/>
+                </a:solidFill>
+                <a:latin typeface="Courier New" pitchFamily="34" charset="0"/>
+                <a:ea typeface="Courier New" pitchFamily="34" charset="-122"/>
+                <a:cs typeface="Courier New" pitchFamily="34" charset="-120"/>
               </a:rPr>
               <a:t>0x3247...</a:t>
             </a:r>
@@ -4443,11 +4443,11 @@
             <a:r>
               <a:rPr lang="en-US" sz="800" dirty="0">
                 <a:solidFill>
-                  <a:srgbClr val="888888"/>
-                </a:solidFill>
-                <a:latin typeface="Consolas" pitchFamily="34" charset="0"/>
-                <a:ea typeface="Consolas" pitchFamily="34" charset="-122"/>
-                <a:cs typeface="Consolas" pitchFamily="34" charset="-120"/>
+                  <a:srgbClr val="666666"/>
+                </a:solidFill>
+                <a:latin typeface="Courier New" pitchFamily="34" charset="0"/>
+                <a:ea typeface="Courier New" pitchFamily="34" charset="-122"/>
+                <a:cs typeface="Courier New" pitchFamily="34" charset="-120"/>
               </a:rPr>
               <a:t>d57d37bd</a:t>
             </a:r>
@@ -4482,7 +4482,7 @@
             <a:r>
               <a:rPr lang="en-US" sz="1000" dirty="0">
                 <a:solidFill>
-                  <a:srgbClr val="888888"/>
+                  <a:srgbClr val="666666"/>
                 </a:solidFill>
               </a:rPr>
               <a:t>Athena · Z.AI Hackathon · GLM-5.1</a:t>
@@ -4505,7 +4505,7 @@
     <p:bg>
       <p:bgPr>
         <a:solidFill>
-          <a:srgbClr val="0A0A0A"/>
+          <a:srgbClr val="000000"/>
         </a:solidFill>
       </p:bgPr>
     </p:bg>
@@ -4552,9 +4552,9 @@
                 <a:solidFill>
                   <a:srgbClr val="FFFFFF"/>
                 </a:solidFill>
-                <a:latin typeface="Arial" pitchFamily="34" charset="0"/>
-                <a:ea typeface="Arial" pitchFamily="34" charset="-122"/>
-                <a:cs typeface="Arial" pitchFamily="34" charset="-120"/>
+                <a:latin typeface="Courier New" pitchFamily="34" charset="0"/>
+                <a:ea typeface="Courier New" pitchFamily="34" charset="-122"/>
+                <a:cs typeface="Courier New" pitchFamily="34" charset="-120"/>
               </a:rPr>
               <a:t>Agent 经济的完整闭环</a:t>
             </a:r>
@@ -4577,11 +4577,11 @@
             <a:avLst/>
           </a:prstGeom>
           <a:solidFill>
-            <a:srgbClr val="1A1F3A"/>
+            <a:srgbClr val="0A0A0A"/>
           </a:solidFill>
           <a:ln w="12700">
             <a:solidFill>
-              <a:srgbClr val="4A90D9"/>
+              <a:srgbClr val="333333"/>
             </a:solidFill>
             <a:prstDash val="solid"/>
           </a:ln>
@@ -4614,11 +4614,11 @@
             <a:r>
               <a:rPr lang="en-US" sz="1400" b="1" dirty="0">
                 <a:solidFill>
-                  <a:srgbClr val="4A90D9"/>
-                </a:solidFill>
-                <a:latin typeface="Arial" pitchFamily="34" charset="0"/>
-                <a:ea typeface="Arial" pitchFamily="34" charset="-122"/>
-                <a:cs typeface="Arial" pitchFamily="34" charset="-120"/>
+                  <a:srgbClr val="333333"/>
+                </a:solidFill>
+                <a:latin typeface="Courier New" pitchFamily="34" charset="0"/>
+                <a:ea typeface="Courier New" pitchFamily="34" charset="-122"/>
+                <a:cs typeface="Courier New" pitchFamily="34" charset="-120"/>
               </a:rPr>
               <a:t>当前模式（人类触发）</a:t>
             </a:r>
@@ -4653,11 +4653,11 @@
             <a:r>
               <a:rPr lang="en-US" sz="1200" dirty="0">
                 <a:solidFill>
-                  <a:srgbClr val="888888"/>
-                </a:solidFill>
-                <a:latin typeface="Arial" pitchFamily="34" charset="0"/>
-                <a:ea typeface="Arial" pitchFamily="34" charset="-122"/>
-                <a:cs typeface="Arial" pitchFamily="34" charset="-120"/>
+                  <a:srgbClr val="666666"/>
+                </a:solidFill>
+                <a:latin typeface="Courier New" pitchFamily="34" charset="0"/>
+                <a:ea typeface="Courier New" pitchFamily="34" charset="-122"/>
+                <a:cs typeface="Courier New" pitchFamily="34" charset="-120"/>
               </a:rPr>
               <a:t>1. 项目方提交合约</a:t>
             </a:r>
@@ -4670,11 +4670,11 @@
             <a:r>
               <a:rPr lang="en-US" sz="1200" dirty="0">
                 <a:solidFill>
-                  <a:srgbClr val="888888"/>
-                </a:solidFill>
-                <a:latin typeface="Arial" pitchFamily="34" charset="0"/>
-                <a:ea typeface="Arial" pitchFamily="34" charset="-122"/>
-                <a:cs typeface="Arial" pitchFamily="34" charset="-120"/>
+                  <a:srgbClr val="666666"/>
+                </a:solidFill>
+                <a:latin typeface="Courier New" pitchFamily="34" charset="0"/>
+                <a:ea typeface="Courier New" pitchFamily="34" charset="-122"/>
+                <a:cs typeface="Courier New" pitchFamily="34" charset="-120"/>
               </a:rPr>
               <a:t>2. Agent 自主审计</a:t>
             </a:r>
@@ -4687,11 +4687,11 @@
             <a:r>
               <a:rPr lang="en-US" sz="1200" dirty="0">
                 <a:solidFill>
-                  <a:srgbClr val="888888"/>
-                </a:solidFill>
-                <a:latin typeface="Arial" pitchFamily="34" charset="0"/>
-                <a:ea typeface="Arial" pitchFamily="34" charset="-122"/>
-                <a:cs typeface="Arial" pitchFamily="34" charset="-120"/>
+                  <a:srgbClr val="666666"/>
+                </a:solidFill>
+                <a:latin typeface="Courier New" pitchFamily="34" charset="0"/>
+                <a:ea typeface="Courier New" pitchFamily="34" charset="-122"/>
+                <a:cs typeface="Courier New" pitchFamily="34" charset="-120"/>
               </a:rPr>
               <a:t>3. 结果自动上链（EAS）</a:t>
             </a:r>
@@ -4704,11 +4704,11 @@
             <a:r>
               <a:rPr lang="en-US" sz="1200" dirty="0">
                 <a:solidFill>
-                  <a:srgbClr val="888888"/>
-                </a:solidFill>
-                <a:latin typeface="Arial" pitchFamily="34" charset="0"/>
-                <a:ea typeface="Arial" pitchFamily="34" charset="-122"/>
-                <a:cs typeface="Arial" pitchFamily="34" charset="-120"/>
+                  <a:srgbClr val="666666"/>
+                </a:solidFill>
+                <a:latin typeface="Courier New" pitchFamily="34" charset="0"/>
+                <a:ea typeface="Courier New" pitchFamily="34" charset="-122"/>
+                <a:cs typeface="Courier New" pitchFamily="34" charset="-120"/>
               </a:rPr>
               <a:t>4. NFT 自动铸造</a:t>
             </a:r>
@@ -4721,11 +4721,11 @@
             <a:r>
               <a:rPr lang="en-US" sz="1200" dirty="0">
                 <a:solidFill>
-                  <a:srgbClr val="888888"/>
-                </a:solidFill>
-                <a:latin typeface="Arial" pitchFamily="34" charset="0"/>
-                <a:ea typeface="Arial" pitchFamily="34" charset="-122"/>
-                <a:cs typeface="Arial" pitchFamily="34" charset="-120"/>
+                  <a:srgbClr val="666666"/>
+                </a:solidFill>
+                <a:latin typeface="Courier New" pitchFamily="34" charset="0"/>
+                <a:ea typeface="Courier New" pitchFamily="34" charset="-122"/>
+                <a:cs typeface="Courier New" pitchFamily="34" charset="-120"/>
               </a:rPr>
               <a:t>5. 项目方支付费用</a:t>
             </a:r>
@@ -4748,7 +4748,7 @@
             <a:avLst/>
           </a:prstGeom>
           <a:solidFill>
-            <a:srgbClr val="1A1F3A"/>
+            <a:srgbClr val="0A0A0A"/>
           </a:solidFill>
           <a:ln w="25400">
             <a:solidFill>
@@ -4787,9 +4787,9 @@
                 <a:solidFill>
                   <a:srgbClr val="D4A535"/>
                 </a:solidFill>
-                <a:latin typeface="Arial" pitchFamily="34" charset="0"/>
-                <a:ea typeface="Arial" pitchFamily="34" charset="-122"/>
-                <a:cs typeface="Arial" pitchFamily="34" charset="-120"/>
+                <a:latin typeface="Courier New" pitchFamily="34" charset="0"/>
+                <a:ea typeface="Courier New" pitchFamily="34" charset="-122"/>
+                <a:cs typeface="Courier New" pitchFamily="34" charset="-120"/>
               </a:rPr>
               <a:t>未来模式（Agent 自主）</a:t>
             </a:r>
@@ -4824,11 +4824,11 @@
             <a:r>
               <a:rPr lang="en-US" sz="1200" dirty="0">
                 <a:solidFill>
-                  <a:srgbClr val="00FF00"/>
-                </a:solidFill>
-                <a:latin typeface="Arial" pitchFamily="34" charset="0"/>
-                <a:ea typeface="Arial" pitchFamily="34" charset="-122"/>
-                <a:cs typeface="Arial" pitchFamily="34" charset="-120"/>
+                  <a:srgbClr val="888888"/>
+                </a:solidFill>
+                <a:latin typeface="Courier New" pitchFamily="34" charset="0"/>
+                <a:ea typeface="Courier New" pitchFamily="34" charset="-122"/>
+                <a:cs typeface="Courier New" pitchFamily="34" charset="-120"/>
               </a:rPr>
               <a:t>1. Agent 监控链上新合约</a:t>
             </a:r>
@@ -4841,11 +4841,11 @@
             <a:r>
               <a:rPr lang="en-US" sz="1200" dirty="0">
                 <a:solidFill>
-                  <a:srgbClr val="00FF00"/>
-                </a:solidFill>
-                <a:latin typeface="Arial" pitchFamily="34" charset="0"/>
-                <a:ea typeface="Arial" pitchFamily="34" charset="-122"/>
-                <a:cs typeface="Arial" pitchFamily="34" charset="-120"/>
+                  <a:srgbClr val="888888"/>
+                </a:solidFill>
+                <a:latin typeface="Courier New" pitchFamily="34" charset="0"/>
+                <a:ea typeface="Courier New" pitchFamily="34" charset="-122"/>
+                <a:cs typeface="Courier New" pitchFamily="34" charset="-120"/>
               </a:rPr>
               <a:t>2. 自动审计</a:t>
             </a:r>
@@ -4858,11 +4858,11 @@
             <a:r>
               <a:rPr lang="en-US" sz="1200" dirty="0">
                 <a:solidFill>
-                  <a:srgbClr val="00FF00"/>
-                </a:solidFill>
-                <a:latin typeface="Arial" pitchFamily="34" charset="0"/>
-                <a:ea typeface="Arial" pitchFamily="34" charset="-122"/>
-                <a:cs typeface="Arial" pitchFamily="34" charset="-120"/>
+                  <a:srgbClr val="888888"/>
+                </a:solidFill>
+                <a:latin typeface="Courier New" pitchFamily="34" charset="0"/>
+                <a:ea typeface="Courier New" pitchFamily="34" charset="-122"/>
+                <a:cs typeface="Courier New" pitchFamily="34" charset="-120"/>
               </a:rPr>
               <a:t>3. 结果自动上链</a:t>
             </a:r>
@@ -4875,11 +4875,11 @@
             <a:r>
               <a:rPr lang="en-US" sz="1200" dirty="0">
                 <a:solidFill>
-                  <a:srgbClr val="00FF00"/>
-                </a:solidFill>
-                <a:latin typeface="Arial" pitchFamily="34" charset="0"/>
-                <a:ea typeface="Arial" pitchFamily="34" charset="-122"/>
-                <a:cs typeface="Arial" pitchFamily="34" charset="-120"/>
+                  <a:srgbClr val="888888"/>
+                </a:solidFill>
+                <a:latin typeface="Courier New" pitchFamily="34" charset="0"/>
+                <a:ea typeface="Courier New" pitchFamily="34" charset="-122"/>
+                <a:cs typeface="Courier New" pitchFamily="34" charset="-120"/>
               </a:rPr>
               <a:t>4. NFT 自动铸造 → 挂单</a:t>
             </a:r>
@@ -4892,11 +4892,11 @@
             <a:r>
               <a:rPr lang="en-US" sz="1200" dirty="0">
                 <a:solidFill>
-                  <a:srgbClr val="00FF00"/>
-                </a:solidFill>
-                <a:latin typeface="Arial" pitchFamily="34" charset="0"/>
-                <a:ea typeface="Arial" pitchFamily="34" charset="-122"/>
-                <a:cs typeface="Arial" pitchFamily="34" charset="-120"/>
+                  <a:srgbClr val="888888"/>
+                </a:solidFill>
+                <a:latin typeface="Courier New" pitchFamily="34" charset="0"/>
+                <a:ea typeface="Courier New" pitchFamily="34" charset="-122"/>
+                <a:cs typeface="Courier New" pitchFamily="34" charset="-120"/>
               </a:rPr>
               <a:t>5. 收入进入 Agent 钱包</a:t>
             </a:r>
@@ -4909,11 +4909,11 @@
             <a:r>
               <a:rPr lang="en-US" sz="1200" dirty="0">
                 <a:solidFill>
-                  <a:srgbClr val="00FF00"/>
-                </a:solidFill>
-                <a:latin typeface="Arial" pitchFamily="34" charset="0"/>
-                <a:ea typeface="Arial" pitchFamily="34" charset="-122"/>
-                <a:cs typeface="Arial" pitchFamily="34" charset="-120"/>
+                  <a:srgbClr val="888888"/>
+                </a:solidFill>
+                <a:latin typeface="Courier New" pitchFamily="34" charset="0"/>
+                <a:ea typeface="Courier New" pitchFamily="34" charset="-122"/>
+                <a:cs typeface="Courier New" pitchFamily="34" charset="-120"/>
               </a:rPr>
               <a:t>6. Agent 购买其他 Agent 服务</a:t>
             </a:r>
@@ -4950,9 +4950,9 @@
                 <a:solidFill>
                   <a:srgbClr val="D4A535"/>
                 </a:solidFill>
-                <a:latin typeface="Arial" pitchFamily="34" charset="0"/>
-                <a:ea typeface="Arial" pitchFamily="34" charset="-122"/>
-                <a:cs typeface="Arial" pitchFamily="34" charset="-120"/>
+                <a:latin typeface="Courier New" pitchFamily="34" charset="0"/>
+                <a:ea typeface="Courier New" pitchFamily="34" charset="-122"/>
+                <a:cs typeface="Courier New" pitchFamily="34" charset="-120"/>
               </a:rPr>
               <a:t>这是 Web3 Agent 经济的雏形。</a:t>
             </a:r>
@@ -4987,7 +4987,7 @@
             <a:r>
               <a:rPr lang="en-US" sz="1000" dirty="0">
                 <a:solidFill>
-                  <a:srgbClr val="888888"/>
+                  <a:srgbClr val="666666"/>
                 </a:solidFill>
               </a:rPr>
               <a:t>Athena · Z.AI Hackathon · GLM-5.1</a:t>

</xml_diff>

<commit_message>
fix: align PPT content with actual workflow (AGENTS.md)
architecture.svg:
- 8 steps now match AGENTS.md (需求理解 → 双引擎扫描 → RAG → PoC → Fuzz → 修复 → EAS → NFT)
- MCP tools: 13 tools with correct categories
- Skill agents: 12 agents with correct names

onchain-verification.svg:
- Removed non-deployed AuditEvidenceChain
- Added Gold NFT minted (Token ID 1)
- Added Schema UID

generate-ppt.js:
- Slide 7: removed fake '.3M attack simulation'
- Added real data: PoC 2/5, Fuzz 256 runs, Slither 4 + Aderyn 3 + Halmos 8
- Fixed EAS link format (/attestation/view/)
</commit_message>
<xml_diff>
--- a/ppt-assets/Athena-Hackathon.pptx
+++ b/ppt-assets/Athena-Hackathon.pptx
@@ -3694,7 +3694,7 @@
                 <a:ea typeface="Courier New" pitchFamily="34" charset="-122"/>
                 <a:cs typeface="Courier New" pitchFamily="34" charset="-120"/>
               </a:rPr>
-              <a:t>攻击模拟：$2.3M 预计损失</a:t>
+              <a:t>PoC 验证：2/5 通过 (Foundry)</a:t>
             </a:r>
             <a:endParaRPr lang="en-US" sz="1000" dirty="0"/>
           </a:p>
@@ -3711,7 +3711,24 @@
                 <a:ea typeface="Courier New" pitchFamily="34" charset="-122"/>
                 <a:cs typeface="Courier New" pitchFamily="34" charset="-120"/>
               </a:rPr>
-              <a:t>PoC 验证：Foundry 256 runs ✓</a:t>
+              <a:t>Fuzz 测试：256 runs ✓</a:t>
+            </a:r>
+            <a:endParaRPr lang="en-US" sz="1000" dirty="0"/>
+          </a:p>
+          <a:p>
+            <a:pPr algn="l" indent="0" marL="0">
+              <a:buNone/>
+            </a:pPr>
+            <a:r>
+              <a:rPr lang="en-US" sz="1000" dirty="0">
+                <a:solidFill>
+                  <a:srgbClr val="666666"/>
+                </a:solidFill>
+                <a:latin typeface="Courier New" pitchFamily="34" charset="0"/>
+                <a:ea typeface="Courier New" pitchFamily="34" charset="-122"/>
+                <a:cs typeface="Courier New" pitchFamily="34" charset="-120"/>
+              </a:rPr>
+              <a:t>静态分析：Slither 4 + Aderyn 3 + Halmos 8</a:t>
             </a:r>
             <a:endParaRPr lang="en-US" sz="1000" dirty="0"/>
           </a:p>

</xml_diff>

<commit_message>
fix: update PPT Roadmap - remove already-implemented items
</commit_message>
<xml_diff>
--- a/ppt-assets/Athena-Hackathon.pptx
+++ b/ppt-assets/Athena-Hackathon.pptx
@@ -1987,6 +1987,10 @@
             <a:prstDash val="solid"/>
           </a:ln>
         </p:spPr>
+        <p:txBody>
+          <a:bodyPr/>
+          <a:p/>
+        </p:txBody>
       </p:sp>
       <p:sp>
         <p:nvSpPr>
@@ -2108,6 +2112,10 @@
             <a:prstDash val="solid"/>
           </a:ln>
         </p:spPr>
+        <p:txBody>
+          <a:bodyPr/>
+          <a:p/>
+        </p:txBody>
       </p:sp>
       <p:sp>
         <p:nvSpPr>
@@ -2165,7 +2173,7 @@
                 <a:ea typeface="Courier New" pitchFamily="34" charset="-122"/>
                 <a:cs typeface="Courier New" pitchFamily="34" charset="-120"/>
               </a:rPr>
-              <a:t>• ZK 隐私审计（v2）</a:t>
+              <a:t>• 主网部署（Ethereum + Base L2）</a:t>
             </a:r>
             <a:endParaRPr lang="en-US" sz="1400" dirty="0"/>
           </a:p>
@@ -2182,7 +2190,7 @@
                 <a:ea typeface="Courier New" pitchFamily="34" charset="-122"/>
                 <a:cs typeface="Courier New" pitchFamily="34" charset="-120"/>
               </a:rPr>
-              <a:t>• 多链部署（Ethereum、Base、Arbitrum）</a:t>
+              <a:t>• 审计报告自动定价（基于合约复杂度）</a:t>
             </a:r>
             <a:endParaRPr lang="en-US" sz="1400" dirty="0"/>
           </a:p>
@@ -2216,7 +2224,7 @@
                 <a:ea typeface="Courier New" pitchFamily="34" charset="-122"/>
                 <a:cs typeface="Courier New" pitchFamily="34" charset="-120"/>
               </a:rPr>
-              <a:t>• 真实协议审计（Curve、Aave）</a:t>
+              <a:t>• 更多协议审计（Aave、Uniswap、Compound）</a:t>
             </a:r>
             <a:endParaRPr lang="en-US" sz="1400" dirty="0"/>
           </a:p>

</xml_diff>

<commit_message>
docs: update roadmap - mark completed items, update next steps
</commit_message>
<xml_diff>
--- a/ppt-assets/Athena-Hackathon.pptx
+++ b/ppt-assets/Athena-Hackathon.pptx
@@ -2173,7 +2173,7 @@
                 <a:ea typeface="Courier New" pitchFamily="34" charset="-122"/>
                 <a:cs typeface="Courier New" pitchFamily="34" charset="-120"/>
               </a:rPr>
-              <a:t>• 主网部署（Ethereum + Base L2）</a:t>
+              <a:t>• 已完成：ZK 隐私审计（Groth16Verifier 链上验证）</a:t>
             </a:r>
             <a:endParaRPr lang="en-US" sz="1400" dirty="0"/>
           </a:p>
@@ -2190,7 +2190,7 @@
                 <a:ea typeface="Courier New" pitchFamily="34" charset="-122"/>
                 <a:cs typeface="Courier New" pitchFamily="34" charset="-120"/>
               </a:rPr>
-              <a:t>• 审计报告自动定价（基于合约复杂度）</a:t>
+              <a:t>• 已完成：多链部署（Sepolia + Base Sepolia 测试网）</a:t>
             </a:r>
             <a:endParaRPr lang="en-US" sz="1400" dirty="0"/>
           </a:p>
@@ -2207,7 +2207,7 @@
                 <a:ea typeface="Courier New" pitchFamily="34" charset="-122"/>
                 <a:cs typeface="Courier New" pitchFamily="34" charset="-120"/>
               </a:rPr>
-              <a:t>• Agent 审计市场（Agent ↔ Agent 交易）</a:t>
+              <a:t>• 已完成：真实协议审计（Curve V2、Hundred Finance）</a:t>
             </a:r>
             <a:endParaRPr lang="en-US" sz="1400" dirty="0"/>
           </a:p>
@@ -2224,7 +2224,7 @@
                 <a:ea typeface="Courier New" pitchFamily="34" charset="-122"/>
                 <a:cs typeface="Courier New" pitchFamily="34" charset="-120"/>
               </a:rPr>
-              <a:t>• 更多协议审计（Aave、Uniswap、Compound）</a:t>
+              <a:t>• 下一步：主网部署 + Agent 审计市场</a:t>
             </a:r>
             <a:endParaRPr lang="en-US" sz="1400" dirty="0"/>
           </a:p>

</xml_diff>